<commit_message>
feat: add PayOS payment integration and admin portal components
</commit_message>
<xml_diff>
--- a/docs/Kiểm thử Hệ thống EVN (2).pptx
+++ b/docs/Kiểm thử Hệ thống EVN (2).pptx
@@ -4,6 +4,9 @@
   <p:sldMasterIdLst>
     <p:sldMasterId id="2147483648" r:id="rId1"/>
   </p:sldMasterIdLst>
+  <p:notesMasterIdLst>
+    <p:notesMasterId r:id="rId14"/>
+  </p:notesMasterIdLst>
   <p:sldIdLst>
     <p:sldId id="256" r:id="rId2"/>
     <p:sldId id="257" r:id="rId3"/>
@@ -22,12 +25,16 @@
   <p:notesSz cx="6858000" cy="9144000"/>
   <p:embeddedFontLst>
     <p:embeddedFont>
-      <p:font typeface="Inter"/>
-      <p:bold r:id="rId14"/>
+      <p:font typeface="Inter" panose="02000503000000020004" pitchFamily="50" charset="0"/>
+      <p:regular r:id="rId15"/>
+      <p:bold r:id="rId16"/>
+      <p:italic r:id="rId17"/>
+      <p:boldItalic r:id="rId18"/>
     </p:embeddedFont>
     <p:embeddedFont>
-      <p:font typeface="Space Grotesk"/>
-      <p:bold r:id="rId15"/>
+      <p:font typeface="Space Grotesk" pitchFamily="2" charset="0"/>
+      <p:regular r:id="rId19"/>
+      <p:bold r:id="rId20"/>
     </p:embeddedFont>
   </p:embeddedFontLst>
   <p:defaultTextStyle>
@@ -144,6 +151,2007 @@
 </p:presentation>
 </file>
 
+<file path=ppt/notesMasters/notesMaster1.xml><?xml version="1.0" encoding="utf-8"?>
+<p:notesMaster xmlns:a="http://schemas.openxmlformats.org/drawingml/2006/main" xmlns:r="http://schemas.openxmlformats.org/officeDocument/2006/relationships" xmlns:p="http://schemas.openxmlformats.org/presentationml/2006/main">
+  <p:cSld>
+    <p:bg>
+      <p:bgRef idx="1001">
+        <a:schemeClr val="bg1"/>
+      </p:bgRef>
+    </p:bg>
+    <p:spTree>
+      <p:nvGrpSpPr>
+        <p:cNvPr id="1" name=""/>
+        <p:cNvGrpSpPr/>
+        <p:nvPr/>
+      </p:nvGrpSpPr>
+      <p:grpSpPr>
+        <a:xfrm>
+          <a:off x="0" y="0"/>
+          <a:ext cx="0" cy="0"/>
+          <a:chOff x="0" y="0"/>
+          <a:chExt cx="0" cy="0"/>
+        </a:xfrm>
+      </p:grpSpPr>
+      <p:sp>
+        <p:nvSpPr>
+          <p:cNvPr id="2" name="Header Placeholder 1"/>
+          <p:cNvSpPr>
+            <a:spLocks noGrp="1"/>
+          </p:cNvSpPr>
+          <p:nvPr>
+            <p:ph type="hdr" sz="quarter"/>
+          </p:nvPr>
+        </p:nvSpPr>
+        <p:spPr>
+          <a:xfrm>
+            <a:off x="0" y="0"/>
+            <a:ext cx="2971800" cy="458788"/>
+          </a:xfrm>
+          <a:prstGeom prst="rect">
+            <a:avLst/>
+          </a:prstGeom>
+        </p:spPr>
+        <p:txBody>
+          <a:bodyPr vert="horz" lIns="91440" tIns="45720" rIns="91440" bIns="45720" rtlCol="0"/>
+          <a:lstStyle>
+            <a:lvl1pPr algn="l">
+              <a:defRPr sz="1200"/>
+            </a:lvl1pPr>
+          </a:lstStyle>
+          <a:p>
+            <a:endParaRPr lang="en-US"/>
+          </a:p>
+        </p:txBody>
+      </p:sp>
+      <p:sp>
+        <p:nvSpPr>
+          <p:cNvPr id="3" name="Date Placeholder 2"/>
+          <p:cNvSpPr>
+            <a:spLocks noGrp="1"/>
+          </p:cNvSpPr>
+          <p:nvPr>
+            <p:ph type="dt" idx="1"/>
+          </p:nvPr>
+        </p:nvSpPr>
+        <p:spPr>
+          <a:xfrm>
+            <a:off x="3884613" y="0"/>
+            <a:ext cx="2971800" cy="458788"/>
+          </a:xfrm>
+          <a:prstGeom prst="rect">
+            <a:avLst/>
+          </a:prstGeom>
+        </p:spPr>
+        <p:txBody>
+          <a:bodyPr vert="horz" lIns="91440" tIns="45720" rIns="91440" bIns="45720" rtlCol="0"/>
+          <a:lstStyle>
+            <a:lvl1pPr algn="r">
+              <a:defRPr sz="1200"/>
+            </a:lvl1pPr>
+          </a:lstStyle>
+          <a:p>
+            <a:fld id="{C71CF0DF-9E48-4796-A52A-732A45960714}" type="datetimeFigureOut">
+              <a:rPr lang="en-US" smtClean="0"/>
+              <a:t>10/23/2026</a:t>
+            </a:fld>
+            <a:endParaRPr lang="en-US"/>
+          </a:p>
+        </p:txBody>
+      </p:sp>
+      <p:sp>
+        <p:nvSpPr>
+          <p:cNvPr id="4" name="Slide Image Placeholder 3"/>
+          <p:cNvSpPr>
+            <a:spLocks noGrp="1" noRot="1" noChangeAspect="1"/>
+          </p:cNvSpPr>
+          <p:nvPr>
+            <p:ph type="sldImg" idx="2"/>
+          </p:nvPr>
+        </p:nvSpPr>
+        <p:spPr>
+          <a:xfrm>
+            <a:off x="685800" y="1143000"/>
+            <a:ext cx="5486400" cy="3086100"/>
+          </a:xfrm>
+          <a:prstGeom prst="rect">
+            <a:avLst/>
+          </a:prstGeom>
+          <a:noFill/>
+          <a:ln w="12700">
+            <a:solidFill>
+              <a:prstClr val="black"/>
+            </a:solidFill>
+          </a:ln>
+        </p:spPr>
+        <p:txBody>
+          <a:bodyPr vert="horz" lIns="91440" tIns="45720" rIns="91440" bIns="45720" rtlCol="0" anchor="ctr"/>
+          <a:lstStyle/>
+          <a:p>
+            <a:endParaRPr lang="en-US"/>
+          </a:p>
+        </p:txBody>
+      </p:sp>
+      <p:sp>
+        <p:nvSpPr>
+          <p:cNvPr id="5" name="Notes Placeholder 4"/>
+          <p:cNvSpPr>
+            <a:spLocks noGrp="1"/>
+          </p:cNvSpPr>
+          <p:nvPr>
+            <p:ph type="body" sz="quarter" idx="3"/>
+          </p:nvPr>
+        </p:nvSpPr>
+        <p:spPr>
+          <a:xfrm>
+            <a:off x="685800" y="4400550"/>
+            <a:ext cx="5486400" cy="3600450"/>
+          </a:xfrm>
+          <a:prstGeom prst="rect">
+            <a:avLst/>
+          </a:prstGeom>
+        </p:spPr>
+        <p:txBody>
+          <a:bodyPr vert="horz" lIns="91440" tIns="45720" rIns="91440" bIns="45720" rtlCol="0"/>
+          <a:lstStyle/>
+          <a:p>
+            <a:pPr lvl="0"/>
+            <a:r>
+              <a:rPr lang="en-US"/>
+              <a:t>Click to edit Master text styles</a:t>
+            </a:r>
+          </a:p>
+          <a:p>
+            <a:pPr lvl="1"/>
+            <a:r>
+              <a:rPr lang="en-US"/>
+              <a:t>Second level</a:t>
+            </a:r>
+          </a:p>
+          <a:p>
+            <a:pPr lvl="2"/>
+            <a:r>
+              <a:rPr lang="en-US"/>
+              <a:t>Third level</a:t>
+            </a:r>
+          </a:p>
+          <a:p>
+            <a:pPr lvl="3"/>
+            <a:r>
+              <a:rPr lang="en-US"/>
+              <a:t>Fourth level</a:t>
+            </a:r>
+          </a:p>
+          <a:p>
+            <a:pPr lvl="4"/>
+            <a:r>
+              <a:rPr lang="en-US"/>
+              <a:t>Fifth level</a:t>
+            </a:r>
+          </a:p>
+        </p:txBody>
+      </p:sp>
+      <p:sp>
+        <p:nvSpPr>
+          <p:cNvPr id="6" name="Footer Placeholder 5"/>
+          <p:cNvSpPr>
+            <a:spLocks noGrp="1"/>
+          </p:cNvSpPr>
+          <p:nvPr>
+            <p:ph type="ftr" sz="quarter" idx="4"/>
+          </p:nvPr>
+        </p:nvSpPr>
+        <p:spPr>
+          <a:xfrm>
+            <a:off x="0" y="8685213"/>
+            <a:ext cx="2971800" cy="458787"/>
+          </a:xfrm>
+          <a:prstGeom prst="rect">
+            <a:avLst/>
+          </a:prstGeom>
+        </p:spPr>
+        <p:txBody>
+          <a:bodyPr vert="horz" lIns="91440" tIns="45720" rIns="91440" bIns="45720" rtlCol="0" anchor="b"/>
+          <a:lstStyle>
+            <a:lvl1pPr algn="l">
+              <a:defRPr sz="1200"/>
+            </a:lvl1pPr>
+          </a:lstStyle>
+          <a:p>
+            <a:endParaRPr lang="en-US"/>
+          </a:p>
+        </p:txBody>
+      </p:sp>
+      <p:sp>
+        <p:nvSpPr>
+          <p:cNvPr id="7" name="Slide Number Placeholder 6"/>
+          <p:cNvSpPr>
+            <a:spLocks noGrp="1"/>
+          </p:cNvSpPr>
+          <p:nvPr>
+            <p:ph type="sldNum" sz="quarter" idx="5"/>
+          </p:nvPr>
+        </p:nvSpPr>
+        <p:spPr>
+          <a:xfrm>
+            <a:off x="3884613" y="8685213"/>
+            <a:ext cx="2971800" cy="458787"/>
+          </a:xfrm>
+          <a:prstGeom prst="rect">
+            <a:avLst/>
+          </a:prstGeom>
+        </p:spPr>
+        <p:txBody>
+          <a:bodyPr vert="horz" lIns="91440" tIns="45720" rIns="91440" bIns="45720" rtlCol="0" anchor="b"/>
+          <a:lstStyle>
+            <a:lvl1pPr algn="r">
+              <a:defRPr sz="1200"/>
+            </a:lvl1pPr>
+          </a:lstStyle>
+          <a:p>
+            <a:fld id="{D6E46A25-E217-42DB-BE17-65A038B23A5C}" type="slidenum">
+              <a:rPr lang="en-US" smtClean="0"/>
+              <a:t>‹#›</a:t>
+            </a:fld>
+            <a:endParaRPr lang="en-US"/>
+          </a:p>
+        </p:txBody>
+      </p:sp>
+    </p:spTree>
+    <p:extLst>
+      <p:ext uri="{BB962C8B-B14F-4D97-AF65-F5344CB8AC3E}">
+        <p14:creationId xmlns:p14="http://schemas.microsoft.com/office/powerpoint/2010/main" val="1982019821"/>
+      </p:ext>
+    </p:extLst>
+  </p:cSld>
+  <p:clrMap bg1="lt1" tx1="dk1" bg2="lt2" tx2="dk2" accent1="accent1" accent2="accent2" accent3="accent3" accent4="accent4" accent5="accent5" accent6="accent6" hlink="hlink" folHlink="folHlink"/>
+  <p:notesStyle>
+    <a:lvl1pPr marL="0" algn="l" defTabSz="914400" rtl="0" eaLnBrk="1" latinLnBrk="0" hangingPunct="1">
+      <a:defRPr sz="1200" kern="1200">
+        <a:solidFill>
+          <a:schemeClr val="tx1"/>
+        </a:solidFill>
+        <a:latin typeface="+mn-lt"/>
+        <a:ea typeface="+mn-ea"/>
+        <a:cs typeface="+mn-cs"/>
+      </a:defRPr>
+    </a:lvl1pPr>
+    <a:lvl2pPr marL="457200" algn="l" defTabSz="914400" rtl="0" eaLnBrk="1" latinLnBrk="0" hangingPunct="1">
+      <a:defRPr sz="1200" kern="1200">
+        <a:solidFill>
+          <a:schemeClr val="tx1"/>
+        </a:solidFill>
+        <a:latin typeface="+mn-lt"/>
+        <a:ea typeface="+mn-ea"/>
+        <a:cs typeface="+mn-cs"/>
+      </a:defRPr>
+    </a:lvl2pPr>
+    <a:lvl3pPr marL="914400" algn="l" defTabSz="914400" rtl="0" eaLnBrk="1" latinLnBrk="0" hangingPunct="1">
+      <a:defRPr sz="1200" kern="1200">
+        <a:solidFill>
+          <a:schemeClr val="tx1"/>
+        </a:solidFill>
+        <a:latin typeface="+mn-lt"/>
+        <a:ea typeface="+mn-ea"/>
+        <a:cs typeface="+mn-cs"/>
+      </a:defRPr>
+    </a:lvl3pPr>
+    <a:lvl4pPr marL="1371600" algn="l" defTabSz="914400" rtl="0" eaLnBrk="1" latinLnBrk="0" hangingPunct="1">
+      <a:defRPr sz="1200" kern="1200">
+        <a:solidFill>
+          <a:schemeClr val="tx1"/>
+        </a:solidFill>
+        <a:latin typeface="+mn-lt"/>
+        <a:ea typeface="+mn-ea"/>
+        <a:cs typeface="+mn-cs"/>
+      </a:defRPr>
+    </a:lvl4pPr>
+    <a:lvl5pPr marL="1828800" algn="l" defTabSz="914400" rtl="0" eaLnBrk="1" latinLnBrk="0" hangingPunct="1">
+      <a:defRPr sz="1200" kern="1200">
+        <a:solidFill>
+          <a:schemeClr val="tx1"/>
+        </a:solidFill>
+        <a:latin typeface="+mn-lt"/>
+        <a:ea typeface="+mn-ea"/>
+        <a:cs typeface="+mn-cs"/>
+      </a:defRPr>
+    </a:lvl5pPr>
+    <a:lvl6pPr marL="2286000" algn="l" defTabSz="914400" rtl="0" eaLnBrk="1" latinLnBrk="0" hangingPunct="1">
+      <a:defRPr sz="1200" kern="1200">
+        <a:solidFill>
+          <a:schemeClr val="tx1"/>
+        </a:solidFill>
+        <a:latin typeface="+mn-lt"/>
+        <a:ea typeface="+mn-ea"/>
+        <a:cs typeface="+mn-cs"/>
+      </a:defRPr>
+    </a:lvl6pPr>
+    <a:lvl7pPr marL="2743200" algn="l" defTabSz="914400" rtl="0" eaLnBrk="1" latinLnBrk="0" hangingPunct="1">
+      <a:defRPr sz="1200" kern="1200">
+        <a:solidFill>
+          <a:schemeClr val="tx1"/>
+        </a:solidFill>
+        <a:latin typeface="+mn-lt"/>
+        <a:ea typeface="+mn-ea"/>
+        <a:cs typeface="+mn-cs"/>
+      </a:defRPr>
+    </a:lvl7pPr>
+    <a:lvl8pPr marL="3200400" algn="l" defTabSz="914400" rtl="0" eaLnBrk="1" latinLnBrk="0" hangingPunct="1">
+      <a:defRPr sz="1200" kern="1200">
+        <a:solidFill>
+          <a:schemeClr val="tx1"/>
+        </a:solidFill>
+        <a:latin typeface="+mn-lt"/>
+        <a:ea typeface="+mn-ea"/>
+        <a:cs typeface="+mn-cs"/>
+      </a:defRPr>
+    </a:lvl8pPr>
+    <a:lvl9pPr marL="3657600" algn="l" defTabSz="914400" rtl="0" eaLnBrk="1" latinLnBrk="0" hangingPunct="1">
+      <a:defRPr sz="1200" kern="1200">
+        <a:solidFill>
+          <a:schemeClr val="tx1"/>
+        </a:solidFill>
+        <a:latin typeface="+mn-lt"/>
+        <a:ea typeface="+mn-ea"/>
+        <a:cs typeface="+mn-cs"/>
+      </a:defRPr>
+    </a:lvl9pPr>
+  </p:notesStyle>
+</p:notesMaster>
+</file>
+
+<file path=ppt/notesSlides/notesSlide1.xml><?xml version="1.0" encoding="utf-8"?>
+<p:notes xmlns:a="http://schemas.openxmlformats.org/drawingml/2006/main" xmlns:r="http://schemas.openxmlformats.org/officeDocument/2006/relationships" xmlns:p="http://schemas.openxmlformats.org/presentationml/2006/main">
+  <p:cSld>
+    <p:spTree>
+      <p:nvGrpSpPr>
+        <p:cNvPr id="1" name=""/>
+        <p:cNvGrpSpPr/>
+        <p:nvPr/>
+      </p:nvGrpSpPr>
+      <p:grpSpPr>
+        <a:xfrm>
+          <a:off x="0" y="0"/>
+          <a:ext cx="0" cy="0"/>
+          <a:chOff x="0" y="0"/>
+          <a:chExt cx="0" cy="0"/>
+        </a:xfrm>
+      </p:grpSpPr>
+      <p:sp>
+        <p:nvSpPr>
+          <p:cNvPr id="2" name="Slide Image Placeholder 1"/>
+          <p:cNvSpPr>
+            <a:spLocks noGrp="1" noRot="1" noChangeAspect="1"/>
+          </p:cNvSpPr>
+          <p:nvPr>
+            <p:ph type="sldImg"/>
+          </p:nvPr>
+        </p:nvSpPr>
+        <p:spPr/>
+      </p:sp>
+      <p:sp>
+        <p:nvSpPr>
+          <p:cNvPr id="3" name="Notes Placeholder 2"/>
+          <p:cNvSpPr>
+            <a:spLocks noGrp="1"/>
+          </p:cNvSpPr>
+          <p:nvPr>
+            <p:ph type="body" idx="1"/>
+          </p:nvPr>
+        </p:nvSpPr>
+        <p:spPr/>
+        <p:txBody>
+          <a:bodyPr/>
+          <a:lstStyle/>
+          <a:p>
+            <a:r>
+              <a:rPr lang="vi-VN" dirty="0"/>
+              <a:t>"Kính chào thầy cô và các bạn. Hôm nay, nhóm chúng em xin đại diện trình bày báo cáo kiểm thử toàn diện cho đề tài **'Hệ Thống Tra Cứu Tiền Điện &amp; Quản Trị Biểu Giá EVN'**. Đề tài của chúng em tập trung vào việc đảm bảo tính chính xác tuyệt đối của thuật toán tính tiền điện lũy kế 6 bậc, kiểm định cơ chế bảo mật thông tin cá nhân 2 lớp, xác thực tích hợp thanh toán trực tuyến đa kênh và vận hành ổn định Trung tâm điều hành ngành điện trên tập dữ liệu lớn. Sau đây em xin phép đi vào chi tiết."</a:t>
+            </a:r>
+            <a:endParaRPr lang="en-US" dirty="0"/>
+          </a:p>
+        </p:txBody>
+      </p:sp>
+      <p:sp>
+        <p:nvSpPr>
+          <p:cNvPr id="4" name="Slide Number Placeholder 3"/>
+          <p:cNvSpPr>
+            <a:spLocks noGrp="1"/>
+          </p:cNvSpPr>
+          <p:nvPr>
+            <p:ph type="sldNum" sz="quarter" idx="5"/>
+          </p:nvPr>
+        </p:nvSpPr>
+        <p:spPr/>
+        <p:txBody>
+          <a:bodyPr/>
+          <a:lstStyle/>
+          <a:p>
+            <a:fld id="{D6E46A25-E217-42DB-BE17-65A038B23A5C}" type="slidenum">
+              <a:rPr lang="en-US" smtClean="0"/>
+              <a:t>1</a:t>
+            </a:fld>
+            <a:endParaRPr lang="en-US"/>
+          </a:p>
+        </p:txBody>
+      </p:sp>
+    </p:spTree>
+    <p:extLst>
+      <p:ext uri="{BB962C8B-B14F-4D97-AF65-F5344CB8AC3E}">
+        <p14:creationId xmlns:p14="http://schemas.microsoft.com/office/powerpoint/2010/main" val="911156101"/>
+      </p:ext>
+    </p:extLst>
+  </p:cSld>
+  <p:clrMapOvr>
+    <a:masterClrMapping/>
+  </p:clrMapOvr>
+</p:notes>
+</file>
+
+<file path=ppt/notesSlides/notesSlide10.xml><?xml version="1.0" encoding="utf-8"?>
+<p:notes xmlns:a="http://schemas.openxmlformats.org/drawingml/2006/main" xmlns:r="http://schemas.openxmlformats.org/officeDocument/2006/relationships" xmlns:p="http://schemas.openxmlformats.org/presentationml/2006/main">
+  <p:cSld>
+    <p:spTree>
+      <p:nvGrpSpPr>
+        <p:cNvPr id="1" name=""/>
+        <p:cNvGrpSpPr/>
+        <p:nvPr/>
+      </p:nvGrpSpPr>
+      <p:grpSpPr>
+        <a:xfrm>
+          <a:off x="0" y="0"/>
+          <a:ext cx="0" cy="0"/>
+          <a:chOff x="0" y="0"/>
+          <a:chExt cx="0" cy="0"/>
+        </a:xfrm>
+      </p:grpSpPr>
+      <p:sp>
+        <p:nvSpPr>
+          <p:cNvPr id="2" name="Slide Image Placeholder 1"/>
+          <p:cNvSpPr>
+            <a:spLocks noGrp="1" noRot="1" noChangeAspect="1"/>
+          </p:cNvSpPr>
+          <p:nvPr>
+            <p:ph type="sldImg"/>
+          </p:nvPr>
+        </p:nvSpPr>
+        <p:spPr/>
+      </p:sp>
+      <p:sp>
+        <p:nvSpPr>
+          <p:cNvPr id="3" name="Notes Placeholder 2"/>
+          <p:cNvSpPr>
+            <a:spLocks noGrp="1"/>
+          </p:cNvSpPr>
+          <p:nvPr>
+            <p:ph type="body" idx="1"/>
+          </p:nvPr>
+        </p:nvSpPr>
+        <p:spPr/>
+        <p:txBody>
+          <a:bodyPr/>
+          <a:lstStyle/>
+          <a:p>
+            <a:r>
+              <a:rPr lang="vi-VN" dirty="0"/>
+              <a:t>"Điểm nhấn về mặt kỹ thuật của nhóm là không phụ thuộc vào các thư viện cồng kềnh như Jest. Chúng em sử dụng trực tiếp bộ Native Test Runner tích hợp sẵn của Node.js, giúp khởi động tức thì.</a:t>
+            </a:r>
+            <a:endParaRPr lang="en-US" dirty="0"/>
+          </a:p>
+          <a:p>
+            <a:endParaRPr lang="en-US" dirty="0"/>
+          </a:p>
+          <a:p>
+            <a:r>
+              <a:rPr lang="vi-VN" dirty="0"/>
+              <a:t>Toàn bộ mã kiểm thử được cấu trúc thành các module độc lập. Đặc biệt, nhóm đã xử lý thành công lỗi xung đột khóa cơ sở dữ liệu SQLite trên Windows bằng cách cấu hình concurrency, giúp toàn bộ 23 kịch bản test tự động chạy và hoàn tất chỉ trong khoảng 2.6 giây với kết quả 100% Passed."</a:t>
+            </a:r>
+            <a:endParaRPr lang="en-US" dirty="0"/>
+          </a:p>
+        </p:txBody>
+      </p:sp>
+      <p:sp>
+        <p:nvSpPr>
+          <p:cNvPr id="4" name="Slide Number Placeholder 3"/>
+          <p:cNvSpPr>
+            <a:spLocks noGrp="1"/>
+          </p:cNvSpPr>
+          <p:nvPr>
+            <p:ph type="sldNum" sz="quarter" idx="5"/>
+          </p:nvPr>
+        </p:nvSpPr>
+        <p:spPr/>
+        <p:txBody>
+          <a:bodyPr/>
+          <a:lstStyle/>
+          <a:p>
+            <a:fld id="{D6E46A25-E217-42DB-BE17-65A038B23A5C}" type="slidenum">
+              <a:rPr lang="en-US" smtClean="0"/>
+              <a:t>10</a:t>
+            </a:fld>
+            <a:endParaRPr lang="en-US"/>
+          </a:p>
+        </p:txBody>
+      </p:sp>
+    </p:spTree>
+    <p:extLst>
+      <p:ext uri="{BB962C8B-B14F-4D97-AF65-F5344CB8AC3E}">
+        <p14:creationId xmlns:p14="http://schemas.microsoft.com/office/powerpoint/2010/main" val="1626363441"/>
+      </p:ext>
+    </p:extLst>
+  </p:cSld>
+  <p:clrMapOvr>
+    <a:masterClrMapping/>
+  </p:clrMapOvr>
+</p:notes>
+</file>
+
+<file path=ppt/notesSlides/notesSlide11.xml><?xml version="1.0" encoding="utf-8"?>
+<p:notes xmlns:a="http://schemas.openxmlformats.org/drawingml/2006/main" xmlns:r="http://schemas.openxmlformats.org/officeDocument/2006/relationships" xmlns:p="http://schemas.openxmlformats.org/presentationml/2006/main">
+  <p:cSld>
+    <p:spTree>
+      <p:nvGrpSpPr>
+        <p:cNvPr id="1" name=""/>
+        <p:cNvGrpSpPr/>
+        <p:nvPr/>
+      </p:nvGrpSpPr>
+      <p:grpSpPr>
+        <a:xfrm>
+          <a:off x="0" y="0"/>
+          <a:ext cx="0" cy="0"/>
+          <a:chOff x="0" y="0"/>
+          <a:chExt cx="0" cy="0"/>
+        </a:xfrm>
+      </p:grpSpPr>
+      <p:sp>
+        <p:nvSpPr>
+          <p:cNvPr id="2" name="Slide Image Placeholder 1"/>
+          <p:cNvSpPr>
+            <a:spLocks noGrp="1" noRot="1" noChangeAspect="1"/>
+          </p:cNvSpPr>
+          <p:nvPr>
+            <p:ph type="sldImg"/>
+          </p:nvPr>
+        </p:nvSpPr>
+        <p:spPr/>
+      </p:sp>
+      <p:sp>
+        <p:nvSpPr>
+          <p:cNvPr id="3" name="Notes Placeholder 2"/>
+          <p:cNvSpPr>
+            <a:spLocks noGrp="1"/>
+          </p:cNvSpPr>
+          <p:nvPr>
+            <p:ph type="body" idx="1"/>
+          </p:nvPr>
+        </p:nvSpPr>
+        <p:spPr/>
+        <p:txBody>
+          <a:bodyPr/>
+          <a:lstStyle/>
+          <a:p>
+            <a:r>
+              <a:rPr lang="en-US" dirty="0"/>
+              <a:t>"</a:t>
+            </a:r>
+            <a:r>
+              <a:rPr lang="en-US" dirty="0" err="1"/>
+              <a:t>Đối</a:t>
+            </a:r>
+            <a:r>
+              <a:rPr lang="en-US" dirty="0"/>
+              <a:t> </a:t>
+            </a:r>
+            <a:r>
+              <a:rPr lang="en-US" dirty="0" err="1"/>
+              <a:t>chiếu</a:t>
+            </a:r>
+            <a:r>
+              <a:rPr lang="en-US" dirty="0"/>
+              <a:t> </a:t>
+            </a:r>
+            <a:r>
+              <a:rPr lang="en-US" dirty="0" err="1"/>
+              <a:t>với</a:t>
+            </a:r>
+            <a:r>
+              <a:rPr lang="en-US" dirty="0"/>
+              <a:t> </a:t>
+            </a:r>
+            <a:r>
+              <a:rPr lang="en-US" dirty="0" err="1"/>
+              <a:t>tiêu</a:t>
+            </a:r>
+            <a:r>
+              <a:rPr lang="en-US" dirty="0"/>
+              <a:t> </a:t>
+            </a:r>
+            <a:r>
+              <a:rPr lang="en-US" dirty="0" err="1"/>
+              <a:t>chuẩn</a:t>
+            </a:r>
+            <a:r>
+              <a:rPr lang="en-US" dirty="0"/>
+              <a:t> </a:t>
+            </a:r>
+            <a:r>
+              <a:rPr lang="en-US" dirty="0" err="1"/>
+              <a:t>nghiệm</a:t>
+            </a:r>
+            <a:r>
+              <a:rPr lang="en-US" dirty="0"/>
+              <a:t> </a:t>
+            </a:r>
+            <a:r>
+              <a:rPr lang="en-US" dirty="0" err="1"/>
+              <a:t>thu</a:t>
+            </a:r>
+            <a:r>
+              <a:rPr lang="en-US" dirty="0"/>
+              <a:t> ban </a:t>
+            </a:r>
+            <a:r>
+              <a:rPr lang="en-US" dirty="0" err="1"/>
+              <a:t>đầu</a:t>
+            </a:r>
+            <a:r>
+              <a:rPr lang="en-US" dirty="0"/>
+              <a:t> </a:t>
+            </a:r>
+            <a:r>
+              <a:rPr lang="en-US" dirty="0" err="1"/>
+              <a:t>đề</a:t>
+            </a:r>
+            <a:r>
+              <a:rPr lang="en-US" dirty="0"/>
+              <a:t> </a:t>
+            </a:r>
+            <a:r>
+              <a:rPr lang="en-US" dirty="0" err="1"/>
+              <a:t>ra</a:t>
+            </a:r>
+            <a:r>
+              <a:rPr lang="en-US" dirty="0"/>
+              <a:t> </a:t>
+            </a:r>
+            <a:r>
+              <a:rPr lang="en-US" dirty="0" err="1"/>
+              <a:t>trong</a:t>
+            </a:r>
+            <a:r>
+              <a:rPr lang="en-US" dirty="0"/>
+              <a:t> Test Plan, </a:t>
+            </a:r>
+            <a:r>
+              <a:rPr lang="en-US" dirty="0" err="1"/>
+              <a:t>hệ</a:t>
+            </a:r>
+            <a:r>
+              <a:rPr lang="en-US" dirty="0"/>
+              <a:t> </a:t>
+            </a:r>
+            <a:r>
+              <a:rPr lang="en-US" dirty="0" err="1"/>
+              <a:t>thống</a:t>
+            </a:r>
+            <a:r>
+              <a:rPr lang="en-US" dirty="0"/>
+              <a:t> </a:t>
+            </a:r>
+            <a:r>
+              <a:rPr lang="en-US" dirty="0" err="1"/>
+              <a:t>đã</a:t>
+            </a:r>
+            <a:r>
+              <a:rPr lang="en-US" dirty="0"/>
+              <a:t> </a:t>
+            </a:r>
+            <a:r>
+              <a:rPr lang="en-US" dirty="0" err="1"/>
+              <a:t>đáp</a:t>
+            </a:r>
+            <a:r>
+              <a:rPr lang="en-US" dirty="0"/>
+              <a:t> </a:t>
+            </a:r>
+            <a:r>
+              <a:rPr lang="en-US" dirty="0" err="1"/>
+              <a:t>ứng</a:t>
+            </a:r>
+            <a:r>
+              <a:rPr lang="en-US" dirty="0"/>
+              <a:t> </a:t>
+            </a:r>
+            <a:r>
+              <a:rPr lang="en-US" dirty="0" err="1"/>
+              <a:t>hoàn</a:t>
+            </a:r>
+            <a:r>
+              <a:rPr lang="en-US" dirty="0"/>
+              <a:t> </a:t>
+            </a:r>
+            <a:r>
+              <a:rPr lang="en-US" dirty="0" err="1"/>
+              <a:t>hảo</a:t>
+            </a:r>
+            <a:r>
+              <a:rPr lang="en-US" dirty="0"/>
+              <a:t>: 100% ca </a:t>
+            </a:r>
+            <a:r>
+              <a:rPr lang="en-US" dirty="0" err="1"/>
+              <a:t>kiểm</a:t>
+            </a:r>
+            <a:r>
+              <a:rPr lang="en-US" dirty="0"/>
+              <a:t> </a:t>
+            </a:r>
+            <a:r>
+              <a:rPr lang="en-US" dirty="0" err="1"/>
+              <a:t>thử</a:t>
+            </a:r>
+            <a:r>
+              <a:rPr lang="en-US" dirty="0"/>
+              <a:t> passed, 0 </a:t>
+            </a:r>
+            <a:r>
+              <a:rPr lang="en-US" dirty="0" err="1"/>
+              <a:t>lỗi</a:t>
+            </a:r>
+            <a:r>
+              <a:rPr lang="en-US" dirty="0"/>
+              <a:t> </a:t>
+            </a:r>
+            <a:r>
+              <a:rPr lang="en-US" dirty="0" err="1"/>
+              <a:t>mức</a:t>
+            </a:r>
+            <a:r>
+              <a:rPr lang="en-US" dirty="0"/>
+              <a:t> </a:t>
+            </a:r>
+            <a:r>
+              <a:rPr lang="en-US" dirty="0" err="1"/>
+              <a:t>độ</a:t>
+            </a:r>
+            <a:r>
+              <a:rPr lang="en-US" dirty="0"/>
+              <a:t> Critical hay Major </a:t>
+            </a:r>
+            <a:r>
+              <a:rPr lang="en-US" dirty="0" err="1"/>
+              <a:t>tồn</a:t>
+            </a:r>
+            <a:r>
+              <a:rPr lang="en-US" dirty="0"/>
+              <a:t> </a:t>
+            </a:r>
+            <a:r>
+              <a:rPr lang="en-US" dirty="0" err="1"/>
+              <a:t>đọng</a:t>
+            </a:r>
+            <a:r>
+              <a:rPr lang="en-US" dirty="0"/>
+              <a:t>. </a:t>
+            </a:r>
+          </a:p>
+          <a:p>
+            <a:endParaRPr lang="en-US" dirty="0"/>
+          </a:p>
+          <a:p>
+            <a:r>
+              <a:rPr lang="en-US" dirty="0" err="1"/>
+              <a:t>Hôm</a:t>
+            </a:r>
+            <a:r>
+              <a:rPr lang="en-US" dirty="0"/>
+              <a:t> nay, </a:t>
+            </a:r>
+            <a:r>
+              <a:rPr lang="en-US" dirty="0" err="1"/>
+              <a:t>nhóm</a:t>
+            </a:r>
+            <a:r>
+              <a:rPr lang="en-US" dirty="0"/>
+              <a:t> </a:t>
+            </a:r>
+            <a:r>
+              <a:rPr lang="en-US" dirty="0" err="1"/>
+              <a:t>chính</a:t>
+            </a:r>
+            <a:r>
+              <a:rPr lang="en-US" dirty="0"/>
+              <a:t> </a:t>
+            </a:r>
+            <a:r>
+              <a:rPr lang="en-US" dirty="0" err="1"/>
+              <a:t>thức</a:t>
+            </a:r>
+            <a:r>
+              <a:rPr lang="en-US" dirty="0"/>
+              <a:t> </a:t>
+            </a:r>
+            <a:r>
+              <a:rPr lang="en-US" dirty="0" err="1"/>
+              <a:t>bàn</a:t>
+            </a:r>
+            <a:r>
+              <a:rPr lang="en-US" dirty="0"/>
+              <a:t> </a:t>
+            </a:r>
+            <a:r>
+              <a:rPr lang="en-US" dirty="0" err="1"/>
+              <a:t>giao</a:t>
+            </a:r>
+            <a:r>
+              <a:rPr lang="en-US" dirty="0"/>
+              <a:t> </a:t>
+            </a:r>
+            <a:r>
+              <a:rPr lang="en-US" dirty="0" err="1"/>
+              <a:t>đầy</a:t>
+            </a:r>
+            <a:r>
+              <a:rPr lang="en-US" dirty="0"/>
+              <a:t> </a:t>
+            </a:r>
+            <a:r>
+              <a:rPr lang="en-US" dirty="0" err="1"/>
+              <a:t>đủ</a:t>
+            </a:r>
+            <a:r>
+              <a:rPr lang="en-US" dirty="0"/>
+              <a:t> 5 </a:t>
+            </a:r>
+            <a:r>
+              <a:rPr lang="en-US" dirty="0" err="1"/>
+              <a:t>bộ</a:t>
+            </a:r>
+            <a:r>
+              <a:rPr lang="en-US" dirty="0"/>
+              <a:t> </a:t>
+            </a:r>
+            <a:r>
+              <a:rPr lang="en-US" dirty="0" err="1"/>
+              <a:t>tài</a:t>
+            </a:r>
+            <a:r>
+              <a:rPr lang="en-US" dirty="0"/>
+              <a:t> </a:t>
+            </a:r>
+            <a:r>
+              <a:rPr lang="en-US" dirty="0" err="1"/>
+              <a:t>liệu</a:t>
+            </a:r>
+            <a:r>
+              <a:rPr lang="en-US" dirty="0"/>
+              <a:t> </a:t>
+            </a:r>
+            <a:r>
+              <a:rPr lang="en-US" dirty="0" err="1"/>
+              <a:t>tiêu</a:t>
+            </a:r>
+            <a:r>
+              <a:rPr lang="en-US" dirty="0"/>
+              <a:t> </a:t>
+            </a:r>
+            <a:r>
+              <a:rPr lang="en-US" dirty="0" err="1"/>
+              <a:t>chuẩn</a:t>
+            </a:r>
+            <a:r>
+              <a:rPr lang="en-US" dirty="0"/>
+              <a:t>: </a:t>
+            </a:r>
+            <a:r>
+              <a:rPr lang="en-US" dirty="0" err="1"/>
+              <a:t>Đặc</a:t>
+            </a:r>
+            <a:r>
+              <a:rPr lang="en-US" dirty="0"/>
+              <a:t> </a:t>
+            </a:r>
+            <a:r>
+              <a:rPr lang="en-US" dirty="0" err="1"/>
+              <a:t>tả</a:t>
+            </a:r>
+            <a:r>
+              <a:rPr lang="en-US" dirty="0"/>
+              <a:t> </a:t>
+            </a:r>
+            <a:r>
+              <a:rPr lang="en-US" dirty="0" err="1"/>
+              <a:t>yêu</a:t>
+            </a:r>
+            <a:r>
+              <a:rPr lang="en-US" dirty="0"/>
+              <a:t> </a:t>
+            </a:r>
+            <a:r>
+              <a:rPr lang="en-US" dirty="0" err="1"/>
+              <a:t>cầu</a:t>
+            </a:r>
+            <a:r>
+              <a:rPr lang="en-US" dirty="0"/>
+              <a:t> (SRS), </a:t>
+            </a:r>
+            <a:r>
+              <a:rPr lang="en-US" dirty="0" err="1"/>
+              <a:t>Kế</a:t>
+            </a:r>
+            <a:r>
+              <a:rPr lang="en-US" dirty="0"/>
+              <a:t> </a:t>
+            </a:r>
+            <a:r>
+              <a:rPr lang="en-US" dirty="0" err="1"/>
+              <a:t>hoạch</a:t>
+            </a:r>
+            <a:r>
+              <a:rPr lang="en-US" dirty="0"/>
+              <a:t> </a:t>
+            </a:r>
+            <a:r>
+              <a:rPr lang="en-US" dirty="0" err="1"/>
+              <a:t>kiểm</a:t>
+            </a:r>
+            <a:r>
+              <a:rPr lang="en-US" dirty="0"/>
+              <a:t> </a:t>
+            </a:r>
+            <a:r>
+              <a:rPr lang="en-US" dirty="0" err="1"/>
+              <a:t>thử</a:t>
+            </a:r>
+            <a:r>
+              <a:rPr lang="en-US" dirty="0"/>
+              <a:t> (Test Plan), Báo </a:t>
+            </a:r>
+            <a:r>
+              <a:rPr lang="en-US" dirty="0" err="1"/>
+              <a:t>cáo</a:t>
+            </a:r>
+            <a:r>
+              <a:rPr lang="en-US" dirty="0"/>
+              <a:t> chi </a:t>
+            </a:r>
+            <a:r>
+              <a:rPr lang="en-US" dirty="0" err="1"/>
+              <a:t>tiết</a:t>
+            </a:r>
+            <a:r>
+              <a:rPr lang="en-US" dirty="0"/>
+              <a:t> 41 Test Cases, Ma </a:t>
+            </a:r>
+            <a:r>
+              <a:rPr lang="en-US" dirty="0" err="1"/>
+              <a:t>trận</a:t>
+            </a:r>
+            <a:r>
+              <a:rPr lang="en-US" dirty="0"/>
+              <a:t> Excel </a:t>
+            </a:r>
+            <a:r>
+              <a:rPr lang="en-US" dirty="0" err="1"/>
+              <a:t>đồng</a:t>
+            </a:r>
+            <a:r>
+              <a:rPr lang="en-US" dirty="0"/>
+              <a:t> </a:t>
+            </a:r>
+            <a:r>
+              <a:rPr lang="en-US" dirty="0" err="1"/>
+              <a:t>bộ</a:t>
+            </a:r>
+            <a:r>
+              <a:rPr lang="en-US" dirty="0"/>
+              <a:t>, </a:t>
+            </a:r>
+            <a:r>
+              <a:rPr lang="en-US" dirty="0" err="1"/>
+              <a:t>cùng</a:t>
+            </a:r>
+            <a:r>
+              <a:rPr lang="en-US" dirty="0"/>
+              <a:t> </a:t>
+            </a:r>
+            <a:r>
+              <a:rPr lang="en-US" dirty="0" err="1"/>
+              <a:t>toàn</a:t>
+            </a:r>
+            <a:r>
+              <a:rPr lang="en-US" dirty="0"/>
+              <a:t> </a:t>
+            </a:r>
+            <a:r>
+              <a:rPr lang="en-US" dirty="0" err="1"/>
+              <a:t>bộ</a:t>
+            </a:r>
+            <a:r>
+              <a:rPr lang="en-US" dirty="0"/>
+              <a:t> </a:t>
+            </a:r>
+            <a:r>
+              <a:rPr lang="en-US" dirty="0" err="1"/>
+              <a:t>mã</a:t>
+            </a:r>
+            <a:r>
+              <a:rPr lang="en-US" dirty="0"/>
+              <a:t> </a:t>
+            </a:r>
+            <a:r>
+              <a:rPr lang="en-US" dirty="0" err="1"/>
+              <a:t>nguồn</a:t>
+            </a:r>
+            <a:r>
+              <a:rPr lang="en-US" dirty="0"/>
+              <a:t> </a:t>
+            </a:r>
+            <a:r>
+              <a:rPr lang="en-US" dirty="0" err="1"/>
+              <a:t>và</a:t>
+            </a:r>
+            <a:r>
+              <a:rPr lang="en-US" dirty="0"/>
+              <a:t> </a:t>
+            </a:r>
+            <a:r>
+              <a:rPr lang="en-US" dirty="0" err="1"/>
+              <a:t>kịch</a:t>
+            </a:r>
+            <a:r>
+              <a:rPr lang="en-US" dirty="0"/>
+              <a:t> </a:t>
+            </a:r>
+            <a:r>
+              <a:rPr lang="en-US" dirty="0" err="1"/>
+              <a:t>bản</a:t>
+            </a:r>
+            <a:r>
+              <a:rPr lang="en-US" dirty="0"/>
+              <a:t> automation."</a:t>
+            </a:r>
+          </a:p>
+        </p:txBody>
+      </p:sp>
+      <p:sp>
+        <p:nvSpPr>
+          <p:cNvPr id="4" name="Slide Number Placeholder 3"/>
+          <p:cNvSpPr>
+            <a:spLocks noGrp="1"/>
+          </p:cNvSpPr>
+          <p:nvPr>
+            <p:ph type="sldNum" sz="quarter" idx="5"/>
+          </p:nvPr>
+        </p:nvSpPr>
+        <p:spPr/>
+        <p:txBody>
+          <a:bodyPr/>
+          <a:lstStyle/>
+          <a:p>
+            <a:fld id="{D6E46A25-E217-42DB-BE17-65A038B23A5C}" type="slidenum">
+              <a:rPr lang="en-US" smtClean="0"/>
+              <a:t>11</a:t>
+            </a:fld>
+            <a:endParaRPr lang="en-US"/>
+          </a:p>
+        </p:txBody>
+      </p:sp>
+    </p:spTree>
+    <p:extLst>
+      <p:ext uri="{BB962C8B-B14F-4D97-AF65-F5344CB8AC3E}">
+        <p14:creationId xmlns:p14="http://schemas.microsoft.com/office/powerpoint/2010/main" val="3174585863"/>
+      </p:ext>
+    </p:extLst>
+  </p:cSld>
+  <p:clrMapOvr>
+    <a:masterClrMapping/>
+  </p:clrMapOvr>
+</p:notes>
+</file>
+
+<file path=ppt/notesSlides/notesSlide12.xml><?xml version="1.0" encoding="utf-8"?>
+<p:notes xmlns:a="http://schemas.openxmlformats.org/drawingml/2006/main" xmlns:r="http://schemas.openxmlformats.org/officeDocument/2006/relationships" xmlns:p="http://schemas.openxmlformats.org/presentationml/2006/main">
+  <p:cSld>
+    <p:spTree>
+      <p:nvGrpSpPr>
+        <p:cNvPr id="1" name=""/>
+        <p:cNvGrpSpPr/>
+        <p:nvPr/>
+      </p:nvGrpSpPr>
+      <p:grpSpPr>
+        <a:xfrm>
+          <a:off x="0" y="0"/>
+          <a:ext cx="0" cy="0"/>
+          <a:chOff x="0" y="0"/>
+          <a:chExt cx="0" cy="0"/>
+        </a:xfrm>
+      </p:grpSpPr>
+      <p:sp>
+        <p:nvSpPr>
+          <p:cNvPr id="2" name="Slide Image Placeholder 1"/>
+          <p:cNvSpPr>
+            <a:spLocks noGrp="1" noRot="1" noChangeAspect="1"/>
+          </p:cNvSpPr>
+          <p:nvPr>
+            <p:ph type="sldImg"/>
+          </p:nvPr>
+        </p:nvSpPr>
+        <p:spPr/>
+      </p:sp>
+      <p:sp>
+        <p:nvSpPr>
+          <p:cNvPr id="3" name="Notes Placeholder 2"/>
+          <p:cNvSpPr>
+            <a:spLocks noGrp="1"/>
+          </p:cNvSpPr>
+          <p:nvPr>
+            <p:ph type="body" idx="1"/>
+          </p:nvPr>
+        </p:nvSpPr>
+        <p:spPr/>
+        <p:txBody>
+          <a:bodyPr/>
+          <a:lstStyle/>
+          <a:p>
+            <a:r>
+              <a:rPr lang="vi-VN" dirty="0"/>
+              <a:t>Qua đồ án này, chúng em đã nắm vững quy trình kiểm định chất lượng phần mềm, từ kỹ thuật thiết kế ca kiểm thử đến tự động hóa API.</a:t>
+            </a:r>
+            <a:endParaRPr lang="en-US" dirty="0"/>
+          </a:p>
+          <a:p>
+            <a:endParaRPr lang="en-US" dirty="0"/>
+          </a:p>
+          <a:p>
+            <a:r>
+              <a:rPr lang="vi-VN" dirty="0"/>
+              <a:t>Em xin chân thành cảm ơn Quý Thầy/Cô đã lắng nghe bài thuyết trình của nhóm. Bây giờ, chúng em xin phép được lắng nghe những câu hỏi và ý kiến đóng góp từ Hội đồng ạ."</a:t>
+            </a:r>
+            <a:endParaRPr lang="en-US" dirty="0"/>
+          </a:p>
+        </p:txBody>
+      </p:sp>
+      <p:sp>
+        <p:nvSpPr>
+          <p:cNvPr id="4" name="Slide Number Placeholder 3"/>
+          <p:cNvSpPr>
+            <a:spLocks noGrp="1"/>
+          </p:cNvSpPr>
+          <p:nvPr>
+            <p:ph type="sldNum" sz="quarter" idx="5"/>
+          </p:nvPr>
+        </p:nvSpPr>
+        <p:spPr/>
+        <p:txBody>
+          <a:bodyPr/>
+          <a:lstStyle/>
+          <a:p>
+            <a:fld id="{D6E46A25-E217-42DB-BE17-65A038B23A5C}" type="slidenum">
+              <a:rPr lang="en-US" smtClean="0"/>
+              <a:t>12</a:t>
+            </a:fld>
+            <a:endParaRPr lang="en-US"/>
+          </a:p>
+        </p:txBody>
+      </p:sp>
+    </p:spTree>
+    <p:extLst>
+      <p:ext uri="{BB962C8B-B14F-4D97-AF65-F5344CB8AC3E}">
+        <p14:creationId xmlns:p14="http://schemas.microsoft.com/office/powerpoint/2010/main" val="2828887060"/>
+      </p:ext>
+    </p:extLst>
+  </p:cSld>
+  <p:clrMapOvr>
+    <a:masterClrMapping/>
+  </p:clrMapOvr>
+</p:notes>
+</file>
+
+<file path=ppt/notesSlides/notesSlide2.xml><?xml version="1.0" encoding="utf-8"?>
+<p:notes xmlns:a="http://schemas.openxmlformats.org/drawingml/2006/main" xmlns:r="http://schemas.openxmlformats.org/officeDocument/2006/relationships" xmlns:p="http://schemas.openxmlformats.org/presentationml/2006/main">
+  <p:cSld>
+    <p:spTree>
+      <p:nvGrpSpPr>
+        <p:cNvPr id="1" name=""/>
+        <p:cNvGrpSpPr/>
+        <p:nvPr/>
+      </p:nvGrpSpPr>
+      <p:grpSpPr>
+        <a:xfrm>
+          <a:off x="0" y="0"/>
+          <a:ext cx="0" cy="0"/>
+          <a:chOff x="0" y="0"/>
+          <a:chExt cx="0" cy="0"/>
+        </a:xfrm>
+      </p:grpSpPr>
+      <p:sp>
+        <p:nvSpPr>
+          <p:cNvPr id="2" name="Slide Image Placeholder 1"/>
+          <p:cNvSpPr>
+            <a:spLocks noGrp="1" noRot="1" noChangeAspect="1"/>
+          </p:cNvSpPr>
+          <p:nvPr>
+            <p:ph type="sldImg"/>
+          </p:nvPr>
+        </p:nvSpPr>
+        <p:spPr/>
+      </p:sp>
+      <p:sp>
+        <p:nvSpPr>
+          <p:cNvPr id="3" name="Notes Placeholder 2"/>
+          <p:cNvSpPr>
+            <a:spLocks noGrp="1"/>
+          </p:cNvSpPr>
+          <p:nvPr>
+            <p:ph type="body" idx="1"/>
+          </p:nvPr>
+        </p:nvSpPr>
+        <p:spPr/>
+        <p:txBody>
+          <a:bodyPr/>
+          <a:lstStyle/>
+          <a:p>
+            <a:r>
+              <a:rPr lang="vi-VN" dirty="0"/>
+              <a:t>"Hệ thống của chúng em phục vụ 2 nhóm người dùng chính: Khách hàng dùng điện và Quản trị viên ngành điện. Vì liên quan trực tiếp đến tiền bạc và dữ liệu cá nhân của người dân, mục tiêu kiểm thử của nhóm đặt ra 3 trọng tâm thiết yếu:*   </a:t>
+            </a:r>
+            <a:endParaRPr lang="en-US" dirty="0"/>
+          </a:p>
+          <a:p>
+            <a:endParaRPr lang="en-US" dirty="0"/>
+          </a:p>
+          <a:p>
+            <a:r>
+              <a:rPr lang="vi-VN" dirty="0"/>
+              <a:t>**Thứ nhất, Tính chính xác:** Độ chính xác tuyệt đối của thuật toán tính tiền điện theo bậc thang, khớp 100% với công thức của Bộ Công Thương.*   </a:t>
+            </a:r>
+            <a:endParaRPr lang="en-US" dirty="0"/>
+          </a:p>
+          <a:p>
+            <a:endParaRPr lang="en-US" dirty="0"/>
+          </a:p>
+          <a:p>
+            <a:r>
+              <a:rPr lang="vi-VN" dirty="0"/>
+              <a:t>**Thứ hai, Bảo mật:** Bảo vệ quyền riêng tư qua cơ chế xác thực số điện thoại 2 lớp, tuyệt đối không rò rỉ thông tin cá nhân.*   </a:t>
+            </a:r>
+            <a:endParaRPr lang="en-US" dirty="0"/>
+          </a:p>
+          <a:p>
+            <a:endParaRPr lang="en-US" dirty="0"/>
+          </a:p>
+          <a:p>
+            <a:r>
+              <a:rPr lang="vi-VN" dirty="0"/>
+              <a:t>**Thứ ba, Hiệu năng:** Đảm bảo hiệu năng xử lý nhanh, phản hồi API dưới 200ms, mượt mà khi tổng hợp số liệu thống kê lớn qua 49 kỳ hóa đơn."</a:t>
+            </a:r>
+            <a:endParaRPr lang="en-US" dirty="0"/>
+          </a:p>
+        </p:txBody>
+      </p:sp>
+      <p:sp>
+        <p:nvSpPr>
+          <p:cNvPr id="4" name="Slide Number Placeholder 3"/>
+          <p:cNvSpPr>
+            <a:spLocks noGrp="1"/>
+          </p:cNvSpPr>
+          <p:nvPr>
+            <p:ph type="sldNum" sz="quarter" idx="5"/>
+          </p:nvPr>
+        </p:nvSpPr>
+        <p:spPr/>
+        <p:txBody>
+          <a:bodyPr/>
+          <a:lstStyle/>
+          <a:p>
+            <a:fld id="{D6E46A25-E217-42DB-BE17-65A038B23A5C}" type="slidenum">
+              <a:rPr lang="en-US" smtClean="0"/>
+              <a:t>2</a:t>
+            </a:fld>
+            <a:endParaRPr lang="en-US"/>
+          </a:p>
+        </p:txBody>
+      </p:sp>
+    </p:spTree>
+    <p:extLst>
+      <p:ext uri="{BB962C8B-B14F-4D97-AF65-F5344CB8AC3E}">
+        <p14:creationId xmlns:p14="http://schemas.microsoft.com/office/powerpoint/2010/main" val="1577642712"/>
+      </p:ext>
+    </p:extLst>
+  </p:cSld>
+  <p:clrMapOvr>
+    <a:masterClrMapping/>
+  </p:clrMapOvr>
+</p:notes>
+</file>
+
+<file path=ppt/notesSlides/notesSlide3.xml><?xml version="1.0" encoding="utf-8"?>
+<p:notes xmlns:a="http://schemas.openxmlformats.org/drawingml/2006/main" xmlns:r="http://schemas.openxmlformats.org/officeDocument/2006/relationships" xmlns:p="http://schemas.openxmlformats.org/presentationml/2006/main">
+  <p:cSld>
+    <p:spTree>
+      <p:nvGrpSpPr>
+        <p:cNvPr id="1" name=""/>
+        <p:cNvGrpSpPr/>
+        <p:nvPr/>
+      </p:nvGrpSpPr>
+      <p:grpSpPr>
+        <a:xfrm>
+          <a:off x="0" y="0"/>
+          <a:ext cx="0" cy="0"/>
+          <a:chOff x="0" y="0"/>
+          <a:chExt cx="0" cy="0"/>
+        </a:xfrm>
+      </p:grpSpPr>
+      <p:sp>
+        <p:nvSpPr>
+          <p:cNvPr id="2" name="Slide Image Placeholder 1"/>
+          <p:cNvSpPr>
+            <a:spLocks noGrp="1" noRot="1" noChangeAspect="1"/>
+          </p:cNvSpPr>
+          <p:nvPr>
+            <p:ph type="sldImg"/>
+          </p:nvPr>
+        </p:nvSpPr>
+        <p:spPr/>
+      </p:sp>
+      <p:sp>
+        <p:nvSpPr>
+          <p:cNvPr id="3" name="Notes Placeholder 2"/>
+          <p:cNvSpPr>
+            <a:spLocks noGrp="1"/>
+          </p:cNvSpPr>
+          <p:nvPr>
+            <p:ph type="body" idx="1"/>
+          </p:nvPr>
+        </p:nvSpPr>
+        <p:spPr/>
+        <p:txBody>
+          <a:bodyPr/>
+          <a:lstStyle/>
+          <a:p>
+            <a:r>
+              <a:rPr lang="vi-VN" dirty="0"/>
+              <a:t>"Về quy trình, nhóm tuân thủ nghiêm ngặt chuẩn quy trình kiểm định phần mềm với 7 mốc công việc rõ ràng.</a:t>
+            </a:r>
+            <a:endParaRPr lang="en-US" dirty="0"/>
+          </a:p>
+          <a:p>
+            <a:endParaRPr lang="en-US" dirty="0"/>
+          </a:p>
+          <a:p>
+            <a:r>
+              <a:rPr lang="vi-VN" dirty="0"/>
+              <a:t>Chúng em bắt đầu từ việc lập Kế hoạch kiểm thử (Test Plan) chi tiết, rà soát tài liệu đặc tả yêu cầu (SRS).</a:t>
+            </a:r>
+            <a:endParaRPr lang="en-US" dirty="0"/>
+          </a:p>
+          <a:p>
+            <a:endParaRPr lang="en-US" dirty="0"/>
+          </a:p>
+          <a:p>
+            <a:r>
+              <a:rPr lang="vi-VN" dirty="0"/>
+              <a:t>Từ đó, thiết kế chi tiết ma trận 41 ca kiểm thử, sau đó tự động hóa bằng code backend và thực hiện kiểm tra chéo (Peer Review) giữa hai thành viên trước khi thực thi nghiệm thu toàn diện để đóng gói sản phẩm."</a:t>
+            </a:r>
+            <a:endParaRPr lang="en-US" dirty="0"/>
+          </a:p>
+        </p:txBody>
+      </p:sp>
+      <p:sp>
+        <p:nvSpPr>
+          <p:cNvPr id="4" name="Slide Number Placeholder 3"/>
+          <p:cNvSpPr>
+            <a:spLocks noGrp="1"/>
+          </p:cNvSpPr>
+          <p:nvPr>
+            <p:ph type="sldNum" sz="quarter" idx="5"/>
+          </p:nvPr>
+        </p:nvSpPr>
+        <p:spPr/>
+        <p:txBody>
+          <a:bodyPr/>
+          <a:lstStyle/>
+          <a:p>
+            <a:fld id="{D6E46A25-E217-42DB-BE17-65A038B23A5C}" type="slidenum">
+              <a:rPr lang="en-US" smtClean="0"/>
+              <a:t>3</a:t>
+            </a:fld>
+            <a:endParaRPr lang="en-US"/>
+          </a:p>
+        </p:txBody>
+      </p:sp>
+    </p:spTree>
+    <p:extLst>
+      <p:ext uri="{BB962C8B-B14F-4D97-AF65-F5344CB8AC3E}">
+        <p14:creationId xmlns:p14="http://schemas.microsoft.com/office/powerpoint/2010/main" val="280734166"/>
+      </p:ext>
+    </p:extLst>
+  </p:cSld>
+  <p:clrMapOvr>
+    <a:masterClrMapping/>
+  </p:clrMapOvr>
+</p:notes>
+</file>
+
+<file path=ppt/notesSlides/notesSlide4.xml><?xml version="1.0" encoding="utf-8"?>
+<p:notes xmlns:a="http://schemas.openxmlformats.org/drawingml/2006/main" xmlns:r="http://schemas.openxmlformats.org/officeDocument/2006/relationships" xmlns:p="http://schemas.openxmlformats.org/presentationml/2006/main">
+  <p:cSld>
+    <p:spTree>
+      <p:nvGrpSpPr>
+        <p:cNvPr id="1" name=""/>
+        <p:cNvGrpSpPr/>
+        <p:nvPr/>
+      </p:nvGrpSpPr>
+      <p:grpSpPr>
+        <a:xfrm>
+          <a:off x="0" y="0"/>
+          <a:ext cx="0" cy="0"/>
+          <a:chOff x="0" y="0"/>
+          <a:chExt cx="0" cy="0"/>
+        </a:xfrm>
+      </p:grpSpPr>
+      <p:sp>
+        <p:nvSpPr>
+          <p:cNvPr id="2" name="Slide Image Placeholder 1"/>
+          <p:cNvSpPr>
+            <a:spLocks noGrp="1" noRot="1" noChangeAspect="1"/>
+          </p:cNvSpPr>
+          <p:nvPr>
+            <p:ph type="sldImg"/>
+          </p:nvPr>
+        </p:nvSpPr>
+        <p:spPr/>
+      </p:sp>
+      <p:sp>
+        <p:nvSpPr>
+          <p:cNvPr id="3" name="Notes Placeholder 2"/>
+          <p:cNvSpPr>
+            <a:spLocks noGrp="1"/>
+          </p:cNvSpPr>
+          <p:nvPr>
+            <p:ph type="body" idx="1"/>
+          </p:nvPr>
+        </p:nvSpPr>
+        <p:spPr/>
+        <p:txBody>
+          <a:bodyPr/>
+          <a:lstStyle/>
+          <a:p>
+            <a:r>
+              <a:rPr lang="vi-VN" dirty="0"/>
+              <a:t>"Để đạt được các mục tiêu trên, nhóm kết hợp đa dạng các kỹ thuật kiểm thử.</a:t>
+            </a:r>
+            <a:endParaRPr lang="en-US" dirty="0"/>
+          </a:p>
+          <a:p>
+            <a:endParaRPr lang="en-US" dirty="0"/>
+          </a:p>
+          <a:p>
+            <a:r>
+              <a:rPr lang="vi-VN" dirty="0"/>
+              <a:t>Với **Hộp đen**, kỹ thuật Phân tích Giá trị biên (BVA) được dùng triệt để tại các mốc nhảy bậc điện như 50, 100, 200 kWh để đảm bảo không bao giờ bị lệch dù chỉ 1 đồng tiền điện. Kỹ thuật Phân vùng tương đương (EP) áp dụng cho việc nhập mã khách hàng và số điện thoại.</a:t>
+            </a:r>
+            <a:endParaRPr lang="en-US" dirty="0"/>
+          </a:p>
+          <a:p>
+            <a:endParaRPr lang="en-US" dirty="0"/>
+          </a:p>
+          <a:p>
+            <a:r>
+              <a:rPr lang="vi-VN" dirty="0"/>
+              <a:t>Bên cạnh đó, chúng em dùng **Hộp trắng** để kiểm tra độ bao phủ nhánh của mã nguồn hàm tính toán, và thực hiện kiểm thử bảo mật API trực tiếp bằng các công cụ dòng lệnh như cURL."</a:t>
+            </a:r>
+            <a:endParaRPr lang="en-US" dirty="0"/>
+          </a:p>
+        </p:txBody>
+      </p:sp>
+      <p:sp>
+        <p:nvSpPr>
+          <p:cNvPr id="4" name="Slide Number Placeholder 3"/>
+          <p:cNvSpPr>
+            <a:spLocks noGrp="1"/>
+          </p:cNvSpPr>
+          <p:nvPr>
+            <p:ph type="sldNum" sz="quarter" idx="5"/>
+          </p:nvPr>
+        </p:nvSpPr>
+        <p:spPr/>
+        <p:txBody>
+          <a:bodyPr/>
+          <a:lstStyle/>
+          <a:p>
+            <a:fld id="{D6E46A25-E217-42DB-BE17-65A038B23A5C}" type="slidenum">
+              <a:rPr lang="en-US" smtClean="0"/>
+              <a:t>4</a:t>
+            </a:fld>
+            <a:endParaRPr lang="en-US"/>
+          </a:p>
+        </p:txBody>
+      </p:sp>
+    </p:spTree>
+    <p:extLst>
+      <p:ext uri="{BB962C8B-B14F-4D97-AF65-F5344CB8AC3E}">
+        <p14:creationId xmlns:p14="http://schemas.microsoft.com/office/powerpoint/2010/main" val="3365415619"/>
+      </p:ext>
+    </p:extLst>
+  </p:cSld>
+  <p:clrMapOvr>
+    <a:masterClrMapping/>
+  </p:clrMapOvr>
+</p:notes>
+</file>
+
+<file path=ppt/notesSlides/notesSlide5.xml><?xml version="1.0" encoding="utf-8"?>
+<p:notes xmlns:a="http://schemas.openxmlformats.org/drawingml/2006/main" xmlns:r="http://schemas.openxmlformats.org/officeDocument/2006/relationships" xmlns:p="http://schemas.openxmlformats.org/presentationml/2006/main">
+  <p:cSld>
+    <p:spTree>
+      <p:nvGrpSpPr>
+        <p:cNvPr id="1" name=""/>
+        <p:cNvGrpSpPr/>
+        <p:nvPr/>
+      </p:nvGrpSpPr>
+      <p:grpSpPr>
+        <a:xfrm>
+          <a:off x="0" y="0"/>
+          <a:ext cx="0" cy="0"/>
+          <a:chOff x="0" y="0"/>
+          <a:chExt cx="0" cy="0"/>
+        </a:xfrm>
+      </p:grpSpPr>
+      <p:sp>
+        <p:nvSpPr>
+          <p:cNvPr id="2" name="Slide Image Placeholder 1"/>
+          <p:cNvSpPr>
+            <a:spLocks noGrp="1" noRot="1" noChangeAspect="1"/>
+          </p:cNvSpPr>
+          <p:nvPr>
+            <p:ph type="sldImg"/>
+          </p:nvPr>
+        </p:nvSpPr>
+        <p:spPr/>
+      </p:sp>
+      <p:sp>
+        <p:nvSpPr>
+          <p:cNvPr id="3" name="Notes Placeholder 2"/>
+          <p:cNvSpPr>
+            <a:spLocks noGrp="1"/>
+          </p:cNvSpPr>
+          <p:nvPr>
+            <p:ph type="body" idx="1"/>
+          </p:nvPr>
+        </p:nvSpPr>
+        <p:spPr/>
+        <p:txBody>
+          <a:bodyPr/>
+          <a:lstStyle/>
+          <a:p>
+            <a:r>
+              <a:rPr lang="vi-VN" dirty="0"/>
+              <a:t>"Tổng cộng, kiến trúc kiểm thử của chúng em bao gồm 41 ca kiểm thử, bao quát toàn bộ 2 phân hệ Khách hàng và Quản trị. Trong đó, có 24 ca được tự động hóa hoàn toàn qua code và 17 ca kiểm thử thủ công để đảm bảo trải nghiệm người dùng thực tế trên giao diện. Tỷ lệ vượt qua (Passed) đạt 100%, hệ thống không còn bất kỳ lỗi nghiêm trọng nào."</a:t>
+            </a:r>
+            <a:endParaRPr lang="en-US" dirty="0"/>
+          </a:p>
+        </p:txBody>
+      </p:sp>
+      <p:sp>
+        <p:nvSpPr>
+          <p:cNvPr id="4" name="Slide Number Placeholder 3"/>
+          <p:cNvSpPr>
+            <a:spLocks noGrp="1"/>
+          </p:cNvSpPr>
+          <p:nvPr>
+            <p:ph type="sldNum" sz="quarter" idx="5"/>
+          </p:nvPr>
+        </p:nvSpPr>
+        <p:spPr/>
+        <p:txBody>
+          <a:bodyPr/>
+          <a:lstStyle/>
+          <a:p>
+            <a:fld id="{D6E46A25-E217-42DB-BE17-65A038B23A5C}" type="slidenum">
+              <a:rPr lang="en-US" smtClean="0"/>
+              <a:t>5</a:t>
+            </a:fld>
+            <a:endParaRPr lang="en-US"/>
+          </a:p>
+        </p:txBody>
+      </p:sp>
+    </p:spTree>
+    <p:extLst>
+      <p:ext uri="{BB962C8B-B14F-4D97-AF65-F5344CB8AC3E}">
+        <p14:creationId xmlns:p14="http://schemas.microsoft.com/office/powerpoint/2010/main" val="216759131"/>
+      </p:ext>
+    </p:extLst>
+  </p:cSld>
+  <p:clrMapOvr>
+    <a:masterClrMapping/>
+  </p:clrMapOvr>
+</p:notes>
+</file>
+
+<file path=ppt/notesSlides/notesSlide6.xml><?xml version="1.0" encoding="utf-8"?>
+<p:notes xmlns:a="http://schemas.openxmlformats.org/drawingml/2006/main" xmlns:r="http://schemas.openxmlformats.org/officeDocument/2006/relationships" xmlns:p="http://schemas.openxmlformats.org/presentationml/2006/main">
+  <p:cSld>
+    <p:spTree>
+      <p:nvGrpSpPr>
+        <p:cNvPr id="1" name=""/>
+        <p:cNvGrpSpPr/>
+        <p:nvPr/>
+      </p:nvGrpSpPr>
+      <p:grpSpPr>
+        <a:xfrm>
+          <a:off x="0" y="0"/>
+          <a:ext cx="0" cy="0"/>
+          <a:chOff x="0" y="0"/>
+          <a:chExt cx="0" cy="0"/>
+        </a:xfrm>
+      </p:grpSpPr>
+      <p:sp>
+        <p:nvSpPr>
+          <p:cNvPr id="2" name="Slide Image Placeholder 1"/>
+          <p:cNvSpPr>
+            <a:spLocks noGrp="1" noRot="1" noChangeAspect="1"/>
+          </p:cNvSpPr>
+          <p:nvPr>
+            <p:ph type="sldImg"/>
+          </p:nvPr>
+        </p:nvSpPr>
+        <p:spPr/>
+      </p:sp>
+      <p:sp>
+        <p:nvSpPr>
+          <p:cNvPr id="3" name="Notes Placeholder 2"/>
+          <p:cNvSpPr>
+            <a:spLocks noGrp="1"/>
+          </p:cNvSpPr>
+          <p:nvPr>
+            <p:ph type="body" idx="1"/>
+          </p:nvPr>
+        </p:nvSpPr>
+        <p:spPr/>
+        <p:txBody>
+          <a:bodyPr/>
+          <a:lstStyle/>
+          <a:p>
+            <a:r>
+              <a:rPr lang="vi-VN" dirty="0"/>
+              <a:t>"Đi vào chi tiết tại Cổng khách hàng, điểm sáng nhất mà nhóm đã kiểm thử thành công là tính năng bảo vệ thông tin cá nhân 2 lớp.</a:t>
+            </a:r>
+            <a:endParaRPr lang="en-US" dirty="0"/>
+          </a:p>
+          <a:p>
+            <a:endParaRPr lang="en-US" dirty="0"/>
+          </a:p>
+          <a:p>
+            <a:r>
+              <a:rPr lang="vi-VN" dirty="0"/>
+              <a:t>Khi một người lạ chỉ biết mã khách hàng (ví dụ KH0001), họ tra cứu thì hệ thống sẽ ẩn danh hoàn toàn, chỉ cho xem số tiền của tháng gần nhất; số điện thoại, địa chỉ hay mã công tơ bị giấu đi cả trên giao diện lẫn trong API backend. Chỉ khi nhập đúng số điện thoại chính chủ thì toàn bộ lịch sử 4 năm và tab biểu đồ mới được mở khóa. Nhóm đã viết cả unit test cho API lẫn kiểm tra giao diện để chứng minh không thể vượt rào bảo mật này."</a:t>
+            </a:r>
+            <a:endParaRPr lang="en-US" dirty="0"/>
+          </a:p>
+        </p:txBody>
+      </p:sp>
+      <p:sp>
+        <p:nvSpPr>
+          <p:cNvPr id="4" name="Slide Number Placeholder 3"/>
+          <p:cNvSpPr>
+            <a:spLocks noGrp="1"/>
+          </p:cNvSpPr>
+          <p:nvPr>
+            <p:ph type="sldNum" sz="quarter" idx="5"/>
+          </p:nvPr>
+        </p:nvSpPr>
+        <p:spPr/>
+        <p:txBody>
+          <a:bodyPr/>
+          <a:lstStyle/>
+          <a:p>
+            <a:fld id="{D6E46A25-E217-42DB-BE17-65A038B23A5C}" type="slidenum">
+              <a:rPr lang="en-US" smtClean="0"/>
+              <a:t>6</a:t>
+            </a:fld>
+            <a:endParaRPr lang="en-US"/>
+          </a:p>
+        </p:txBody>
+      </p:sp>
+    </p:spTree>
+    <p:extLst>
+      <p:ext uri="{BB962C8B-B14F-4D97-AF65-F5344CB8AC3E}">
+        <p14:creationId xmlns:p14="http://schemas.microsoft.com/office/powerpoint/2010/main" val="710152698"/>
+      </p:ext>
+    </p:extLst>
+  </p:cSld>
+  <p:clrMapOvr>
+    <a:masterClrMapping/>
+  </p:clrMapOvr>
+</p:notes>
+</file>
+
+<file path=ppt/notesSlides/notesSlide7.xml><?xml version="1.0" encoding="utf-8"?>
+<p:notes xmlns:a="http://schemas.openxmlformats.org/drawingml/2006/main" xmlns:r="http://schemas.openxmlformats.org/officeDocument/2006/relationships" xmlns:p="http://schemas.openxmlformats.org/presentationml/2006/main">
+  <p:cSld>
+    <p:spTree>
+      <p:nvGrpSpPr>
+        <p:cNvPr id="1" name=""/>
+        <p:cNvGrpSpPr/>
+        <p:nvPr/>
+      </p:nvGrpSpPr>
+      <p:grpSpPr>
+        <a:xfrm>
+          <a:off x="0" y="0"/>
+          <a:ext cx="0" cy="0"/>
+          <a:chOff x="0" y="0"/>
+          <a:chExt cx="0" cy="0"/>
+        </a:xfrm>
+      </p:grpSpPr>
+      <p:sp>
+        <p:nvSpPr>
+          <p:cNvPr id="2" name="Slide Image Placeholder 1"/>
+          <p:cNvSpPr>
+            <a:spLocks noGrp="1" noRot="1" noChangeAspect="1"/>
+          </p:cNvSpPr>
+          <p:nvPr>
+            <p:ph type="sldImg"/>
+          </p:nvPr>
+        </p:nvSpPr>
+        <p:spPr/>
+      </p:sp>
+      <p:sp>
+        <p:nvSpPr>
+          <p:cNvPr id="3" name="Notes Placeholder 2"/>
+          <p:cNvSpPr>
+            <a:spLocks noGrp="1"/>
+          </p:cNvSpPr>
+          <p:nvPr>
+            <p:ph type="body" idx="1"/>
+          </p:nvPr>
+        </p:nvSpPr>
+        <p:spPr/>
+        <p:txBody>
+          <a:bodyPr/>
+          <a:lstStyle/>
+          <a:p>
+            <a:r>
+              <a:rPr lang="vi-VN" dirty="0"/>
+              <a:t>"Chuyển sang phân hệ Quản trị viên, chúng em tập trung kiểm định các chức năng Quản lý dữ liệu (CRUD) và tính toán động. Quản trị viên có thể tìm kiếm khách hàng thông minh (hỗ trợ tiếng Việt có dấu), cấu hình điều chỉnh đơn giá bậc 1 hoặc thay đổi thuế VAT, và hệ thống phải ngay lập tức tính toán lại chính xác trên hóa đơn.</a:t>
+            </a:r>
+            <a:endParaRPr lang="en-US" dirty="0"/>
+          </a:p>
+          <a:p>
+            <a:endParaRPr lang="en-US" dirty="0"/>
+          </a:p>
+          <a:p>
+            <a:r>
+              <a:rPr lang="vi-VN" dirty="0"/>
+              <a:t>Các bài Unit Test cho thuật toán tính tiền 6 bậc được kiểm chứng độc lập, đối soát từng số lẻ, từng đồng thuế VAT với hóa đơn thực tế của Tập đoàn Điện lực Việt Nam, đảm bảo tính đúng đắn tuyệt đối."</a:t>
+            </a:r>
+            <a:endParaRPr lang="en-US" dirty="0"/>
+          </a:p>
+        </p:txBody>
+      </p:sp>
+      <p:sp>
+        <p:nvSpPr>
+          <p:cNvPr id="4" name="Slide Number Placeholder 3"/>
+          <p:cNvSpPr>
+            <a:spLocks noGrp="1"/>
+          </p:cNvSpPr>
+          <p:nvPr>
+            <p:ph type="sldNum" sz="quarter" idx="5"/>
+          </p:nvPr>
+        </p:nvSpPr>
+        <p:spPr/>
+        <p:txBody>
+          <a:bodyPr/>
+          <a:lstStyle/>
+          <a:p>
+            <a:fld id="{D6E46A25-E217-42DB-BE17-65A038B23A5C}" type="slidenum">
+              <a:rPr lang="en-US" smtClean="0"/>
+              <a:t>7</a:t>
+            </a:fld>
+            <a:endParaRPr lang="en-US"/>
+          </a:p>
+        </p:txBody>
+      </p:sp>
+    </p:spTree>
+    <p:extLst>
+      <p:ext uri="{BB962C8B-B14F-4D97-AF65-F5344CB8AC3E}">
+        <p14:creationId xmlns:p14="http://schemas.microsoft.com/office/powerpoint/2010/main" val="2530351679"/>
+      </p:ext>
+    </p:extLst>
+  </p:cSld>
+  <p:clrMapOvr>
+    <a:masterClrMapping/>
+  </p:clrMapOvr>
+</p:notes>
+</file>
+
+<file path=ppt/notesSlides/notesSlide8.xml><?xml version="1.0" encoding="utf-8"?>
+<p:notes xmlns:a="http://schemas.openxmlformats.org/drawingml/2006/main" xmlns:r="http://schemas.openxmlformats.org/officeDocument/2006/relationships" xmlns:p="http://schemas.openxmlformats.org/presentationml/2006/main">
+  <p:cSld>
+    <p:spTree>
+      <p:nvGrpSpPr>
+        <p:cNvPr id="1" name=""/>
+        <p:cNvGrpSpPr/>
+        <p:nvPr/>
+      </p:nvGrpSpPr>
+      <p:grpSpPr>
+        <a:xfrm>
+          <a:off x="0" y="0"/>
+          <a:ext cx="0" cy="0"/>
+          <a:chOff x="0" y="0"/>
+          <a:chExt cx="0" cy="0"/>
+        </a:xfrm>
+      </p:grpSpPr>
+      <p:sp>
+        <p:nvSpPr>
+          <p:cNvPr id="2" name="Slide Image Placeholder 1"/>
+          <p:cNvSpPr>
+            <a:spLocks noGrp="1" noRot="1" noChangeAspect="1"/>
+          </p:cNvSpPr>
+          <p:nvPr>
+            <p:ph type="sldImg"/>
+          </p:nvPr>
+        </p:nvSpPr>
+        <p:spPr/>
+      </p:sp>
+      <p:sp>
+        <p:nvSpPr>
+          <p:cNvPr id="3" name="Notes Placeholder 2"/>
+          <p:cNvSpPr>
+            <a:spLocks noGrp="1"/>
+          </p:cNvSpPr>
+          <p:nvPr>
+            <p:ph type="body" idx="1"/>
+          </p:nvPr>
+        </p:nvSpPr>
+        <p:spPr/>
+        <p:txBody>
+          <a:bodyPr/>
+          <a:lstStyle/>
+          <a:p>
+            <a:r>
+              <a:rPr lang="vi-VN" dirty="0"/>
+              <a:t>"Một tính năng vượt trội khác trong đồ án là Trung tâm điều hành ngành điện (Dashboard). Với cơ sở dữ liệu lớn mô phỏng gồm hơn 27 nghìn bản ghi chỉ số qua 49 kỳ, API Dashboard của chúng em đã vượt qua bài test hiệu năng: tính toán tổng hợp 5 chỉ số Bento KPI và vẽ mượt mà 4 biểu đồ phân tích trực quan. Nhóm cũng đã kiểm thử thành công luồng drill-down xem chi tiết từng kỳ và lọc ra Top 20 khách hàng nợ cước lớn nhất để phục vụ công tác điều hành."</a:t>
+            </a:r>
+            <a:endParaRPr lang="en-US" dirty="0"/>
+          </a:p>
+        </p:txBody>
+      </p:sp>
+      <p:sp>
+        <p:nvSpPr>
+          <p:cNvPr id="4" name="Slide Number Placeholder 3"/>
+          <p:cNvSpPr>
+            <a:spLocks noGrp="1"/>
+          </p:cNvSpPr>
+          <p:nvPr>
+            <p:ph type="sldNum" sz="quarter" idx="5"/>
+          </p:nvPr>
+        </p:nvSpPr>
+        <p:spPr/>
+        <p:txBody>
+          <a:bodyPr/>
+          <a:lstStyle/>
+          <a:p>
+            <a:fld id="{D6E46A25-E217-42DB-BE17-65A038B23A5C}" type="slidenum">
+              <a:rPr lang="en-US" smtClean="0"/>
+              <a:t>8</a:t>
+            </a:fld>
+            <a:endParaRPr lang="en-US"/>
+          </a:p>
+        </p:txBody>
+      </p:sp>
+    </p:spTree>
+    <p:extLst>
+      <p:ext uri="{BB962C8B-B14F-4D97-AF65-F5344CB8AC3E}">
+        <p14:creationId xmlns:p14="http://schemas.microsoft.com/office/powerpoint/2010/main" val="1123240215"/>
+      </p:ext>
+    </p:extLst>
+  </p:cSld>
+  <p:clrMapOvr>
+    <a:masterClrMapping/>
+  </p:clrMapOvr>
+</p:notes>
+</file>
+
+<file path=ppt/notesSlides/notesSlide9.xml><?xml version="1.0" encoding="utf-8"?>
+<p:notes xmlns:a="http://schemas.openxmlformats.org/drawingml/2006/main" xmlns:r="http://schemas.openxmlformats.org/officeDocument/2006/relationships" xmlns:p="http://schemas.openxmlformats.org/presentationml/2006/main">
+  <p:cSld>
+    <p:spTree>
+      <p:nvGrpSpPr>
+        <p:cNvPr id="1" name=""/>
+        <p:cNvGrpSpPr/>
+        <p:nvPr/>
+      </p:nvGrpSpPr>
+      <p:grpSpPr>
+        <a:xfrm>
+          <a:off x="0" y="0"/>
+          <a:ext cx="0" cy="0"/>
+          <a:chOff x="0" y="0"/>
+          <a:chExt cx="0" cy="0"/>
+        </a:xfrm>
+      </p:grpSpPr>
+      <p:sp>
+        <p:nvSpPr>
+          <p:cNvPr id="2" name="Slide Image Placeholder 1"/>
+          <p:cNvSpPr>
+            <a:spLocks noGrp="1" noRot="1" noChangeAspect="1"/>
+          </p:cNvSpPr>
+          <p:nvPr>
+            <p:ph type="sldImg"/>
+          </p:nvPr>
+        </p:nvSpPr>
+        <p:spPr/>
+      </p:sp>
+      <p:sp>
+        <p:nvSpPr>
+          <p:cNvPr id="3" name="Notes Placeholder 2"/>
+          <p:cNvSpPr>
+            <a:spLocks noGrp="1"/>
+          </p:cNvSpPr>
+          <p:nvPr>
+            <p:ph type="body" idx="1"/>
+          </p:nvPr>
+        </p:nvSpPr>
+        <p:spPr/>
+        <p:txBody>
+          <a:bodyPr/>
+          <a:lstStyle/>
+          <a:p>
+            <a:r>
+              <a:rPr lang="vi-VN" dirty="0"/>
+              <a:t>"Về mảng thanh toán, chúng em kiểm thử tích hợp cổng thanh toán thực tế phổ biến tại Việt Nam là PayOS VietQR, đảm bảo đầy đủ mã băm an toàn HMAC-SHA512.</a:t>
+            </a:r>
+            <a:endParaRPr lang="en-US" dirty="0"/>
+          </a:p>
+          <a:p>
+            <a:endParaRPr lang="en-US" dirty="0"/>
+          </a:p>
+          <a:p>
+            <a:r>
+              <a:rPr lang="vi-VN" dirty="0"/>
+              <a:t>Về mặt giao diện, chúng em kiểm định nghiêm ngặt tính nhất quán của phong cách Flat UI tối giản, các con số tài chính được căn gióng thẳng hàng chuẩn mực bằng font kỹ thuật JetBrains Mono, cùng hệ thống màu pastel báo hiệu trạng thái thanh toán trực quan."</a:t>
+            </a:r>
+            <a:endParaRPr lang="en-US" dirty="0"/>
+          </a:p>
+        </p:txBody>
+      </p:sp>
+      <p:sp>
+        <p:nvSpPr>
+          <p:cNvPr id="4" name="Slide Number Placeholder 3"/>
+          <p:cNvSpPr>
+            <a:spLocks noGrp="1"/>
+          </p:cNvSpPr>
+          <p:nvPr>
+            <p:ph type="sldNum" sz="quarter" idx="5"/>
+          </p:nvPr>
+        </p:nvSpPr>
+        <p:spPr/>
+        <p:txBody>
+          <a:bodyPr/>
+          <a:lstStyle/>
+          <a:p>
+            <a:fld id="{D6E46A25-E217-42DB-BE17-65A038B23A5C}" type="slidenum">
+              <a:rPr lang="en-US" smtClean="0"/>
+              <a:t>9</a:t>
+            </a:fld>
+            <a:endParaRPr lang="en-US"/>
+          </a:p>
+        </p:txBody>
+      </p:sp>
+    </p:spTree>
+    <p:extLst>
+      <p:ext uri="{BB962C8B-B14F-4D97-AF65-F5344CB8AC3E}">
+        <p14:creationId xmlns:p14="http://schemas.microsoft.com/office/powerpoint/2010/main" val="2729850036"/>
+      </p:ext>
+    </p:extLst>
+  </p:cSld>
+  <p:clrMapOvr>
+    <a:masterClrMapping/>
+  </p:clrMapOvr>
+</p:notes>
+</file>
+
 <file path=ppt/slideLayouts/slideLayout1.xml><?xml version="1.0" encoding="utf-8"?>
 <p:sldLayout xmlns:a="http://schemas.openxmlformats.org/drawingml/2006/main" xmlns:r="http://schemas.openxmlformats.org/officeDocument/2006/relationships" xmlns:p="http://schemas.openxmlformats.org/presentationml/2006/main" type="title" preserve="1">
   <p:cSld name="Title Slide">
@@ -323,7 +2331,7 @@
           <a:p>
             <a:fld id="{5BCAD085-E8A6-8845-BD4E-CB4CCA059FC4}" type="datetimeFigureOut">
               <a:rPr lang="en-US" smtClean="0"/>
-              <a:t>10/22/2026</a:t>
+              <a:t>10/23/2026</a:t>
             </a:fld>
             <a:endParaRPr lang="en-US"/>
           </a:p>
@@ -491,7 +2499,7 @@
           <a:p>
             <a:fld id="{5BCAD085-E8A6-8845-BD4E-CB4CCA059FC4}" type="datetimeFigureOut">
               <a:rPr lang="en-US" smtClean="0"/>
-              <a:t>10/22/2026</a:t>
+              <a:t>10/23/2026</a:t>
             </a:fld>
             <a:endParaRPr lang="en-US"/>
           </a:p>
@@ -669,7 +2677,7 @@
           <a:p>
             <a:fld id="{5BCAD085-E8A6-8845-BD4E-CB4CCA059FC4}" type="datetimeFigureOut">
               <a:rPr lang="en-US" smtClean="0"/>
-              <a:t>10/22/2026</a:t>
+              <a:t>10/23/2026</a:t>
             </a:fld>
             <a:endParaRPr lang="en-US"/>
           </a:p>
@@ -837,7 +2845,7 @@
           <a:p>
             <a:fld id="{5BCAD085-E8A6-8845-BD4E-CB4CCA059FC4}" type="datetimeFigureOut">
               <a:rPr lang="en-US" smtClean="0"/>
-              <a:t>10/22/2026</a:t>
+              <a:t>10/23/2026</a:t>
             </a:fld>
             <a:endParaRPr lang="en-US"/>
           </a:p>
@@ -1082,7 +3090,7 @@
           <a:p>
             <a:fld id="{5BCAD085-E8A6-8845-BD4E-CB4CCA059FC4}" type="datetimeFigureOut">
               <a:rPr lang="en-US" smtClean="0"/>
-              <a:t>10/22/2026</a:t>
+              <a:t>10/23/2026</a:t>
             </a:fld>
             <a:endParaRPr lang="en-US"/>
           </a:p>
@@ -1367,7 +3375,7 @@
           <a:p>
             <a:fld id="{5BCAD085-E8A6-8845-BD4E-CB4CCA059FC4}" type="datetimeFigureOut">
               <a:rPr lang="en-US" smtClean="0"/>
-              <a:t>10/22/2026</a:t>
+              <a:t>10/23/2026</a:t>
             </a:fld>
             <a:endParaRPr lang="en-US"/>
           </a:p>
@@ -1786,7 +3794,7 @@
           <a:p>
             <a:fld id="{5BCAD085-E8A6-8845-BD4E-CB4CCA059FC4}" type="datetimeFigureOut">
               <a:rPr lang="en-US" smtClean="0"/>
-              <a:t>10/22/2026</a:t>
+              <a:t>10/23/2026</a:t>
             </a:fld>
             <a:endParaRPr lang="en-US"/>
           </a:p>
@@ -1903,7 +3911,7 @@
           <a:p>
             <a:fld id="{5BCAD085-E8A6-8845-BD4E-CB4CCA059FC4}" type="datetimeFigureOut">
               <a:rPr lang="en-US" smtClean="0"/>
-              <a:t>10/22/2026</a:t>
+              <a:t>10/23/2026</a:t>
             </a:fld>
             <a:endParaRPr lang="en-US"/>
           </a:p>
@@ -1998,7 +4006,7 @@
           <a:p>
             <a:fld id="{5BCAD085-E8A6-8845-BD4E-CB4CCA059FC4}" type="datetimeFigureOut">
               <a:rPr lang="en-US" smtClean="0"/>
-              <a:t>10/22/2026</a:t>
+              <a:t>10/23/2026</a:t>
             </a:fld>
             <a:endParaRPr lang="en-US"/>
           </a:p>
@@ -2273,7 +4281,7 @@
           <a:p>
             <a:fld id="{5BCAD085-E8A6-8845-BD4E-CB4CCA059FC4}" type="datetimeFigureOut">
               <a:rPr lang="en-US" smtClean="0"/>
-              <a:t>10/22/2026</a:t>
+              <a:t>10/23/2026</a:t>
             </a:fld>
             <a:endParaRPr lang="en-US"/>
           </a:p>
@@ -2525,7 +4533,7 @@
           <a:p>
             <a:fld id="{5BCAD085-E8A6-8845-BD4E-CB4CCA059FC4}" type="datetimeFigureOut">
               <a:rPr lang="en-US" smtClean="0"/>
-              <a:t>10/22/2026</a:t>
+              <a:t>10/23/2026</a:t>
             </a:fld>
             <a:endParaRPr lang="en-US"/>
           </a:p>
@@ -2736,7 +4744,7 @@
           <a:p>
             <a:fld id="{5BCAD085-E8A6-8845-BD4E-CB4CCA059FC4}" type="datetimeFigureOut">
               <a:rPr lang="en-US" smtClean="0"/>
-              <a:t>10/22/2026</a:t>
+              <a:t>10/23/2026</a:t>
             </a:fld>
             <a:endParaRPr lang="en-US"/>
           </a:p>
@@ -6055,13 +8063,94 @@
               </a:lnSpc>
             </a:pPr>
             <a:r>
-              <a:rPr sz="1800" b="0" i="0" u="none">
+              <a:rPr sz="1800" b="0" i="0" u="none" dirty="0" err="1">
                 <a:solidFill>
                   <a:srgbClr val="000000"/>
                 </a:solidFill>
                 <a:latin typeface="Inter"/>
               </a:rPr>
-              <a:t>Soạn thảo Test Plan v1.2, phân chia tài nguyên.</a:t>
+              <a:t>Soạn</a:t>
+            </a:r>
+            <a:r>
+              <a:rPr sz="1800" b="0" i="0" u="none" dirty="0">
+                <a:solidFill>
+                  <a:srgbClr val="000000"/>
+                </a:solidFill>
+                <a:latin typeface="Inter"/>
+              </a:rPr>
+              <a:t> </a:t>
+            </a:r>
+            <a:r>
+              <a:rPr sz="1800" b="0" i="0" u="none" dirty="0" err="1">
+                <a:solidFill>
+                  <a:srgbClr val="000000"/>
+                </a:solidFill>
+                <a:latin typeface="Inter"/>
+              </a:rPr>
+              <a:t>thảo</a:t>
+            </a:r>
+            <a:r>
+              <a:rPr sz="1800" b="0" i="0" u="none" dirty="0">
+                <a:solidFill>
+                  <a:srgbClr val="000000"/>
+                </a:solidFill>
+                <a:latin typeface="Inter"/>
+              </a:rPr>
+              <a:t> Test Plan, </a:t>
+            </a:r>
+            <a:r>
+              <a:rPr sz="1800" b="0" i="0" u="none" dirty="0" err="1">
+                <a:solidFill>
+                  <a:srgbClr val="000000"/>
+                </a:solidFill>
+                <a:latin typeface="Inter"/>
+              </a:rPr>
+              <a:t>phân</a:t>
+            </a:r>
+            <a:r>
+              <a:rPr sz="1800" b="0" i="0" u="none" dirty="0">
+                <a:solidFill>
+                  <a:srgbClr val="000000"/>
+                </a:solidFill>
+                <a:latin typeface="Inter"/>
+              </a:rPr>
+              <a:t> chia </a:t>
+            </a:r>
+            <a:r>
+              <a:rPr sz="1800" b="0" i="0" u="none" dirty="0" err="1">
+                <a:solidFill>
+                  <a:srgbClr val="000000"/>
+                </a:solidFill>
+                <a:latin typeface="Inter"/>
+              </a:rPr>
+              <a:t>tài</a:t>
+            </a:r>
+            <a:r>
+              <a:rPr sz="1800" b="0" i="0" u="none" dirty="0">
+                <a:solidFill>
+                  <a:srgbClr val="000000"/>
+                </a:solidFill>
+                <a:latin typeface="Inter"/>
+              </a:rPr>
+              <a:t> </a:t>
+            </a:r>
+            <a:r>
+              <a:rPr sz="1800" b="0" i="0" u="none" dirty="0" err="1">
+                <a:solidFill>
+                  <a:srgbClr val="000000"/>
+                </a:solidFill>
+                <a:latin typeface="Inter"/>
+              </a:rPr>
+              <a:t>nguyên</a:t>
+            </a:r>
+            <a:r>
+              <a:rPr sz="1800" b="0" i="0" u="none" dirty="0">
+                <a:solidFill>
+                  <a:srgbClr val="000000"/>
+                </a:solidFill>
+                <a:latin typeface="Inter"/>
+              </a:rPr>
+              <a:t>.</a:t>
             </a:r>
           </a:p>
         </p:txBody>
@@ -7481,7 +9570,7 @@
           <p:nvPr/>
         </p:nvPicPr>
         <p:blipFill>
-          <a:blip r:embed="rId2"/>
+          <a:blip r:embed="rId3"/>
           <a:stretch>
             <a:fillRect/>
           </a:stretch>
@@ -7505,7 +9594,7 @@
           <p:nvPr/>
         </p:nvPicPr>
         <p:blipFill>
-          <a:blip r:embed="rId3"/>
+          <a:blip r:embed="rId4"/>
           <a:stretch>
             <a:fillRect/>
           </a:stretch>
@@ -7529,7 +9618,7 @@
           <p:nvPr/>
         </p:nvPicPr>
         <p:blipFill>
-          <a:blip r:embed="rId4"/>
+          <a:blip r:embed="rId5"/>
           <a:stretch>
             <a:fillRect/>
           </a:stretch>
@@ -10049,4 +12138,319 @@
   </a:objectDefaults>
   <a:extraClrSchemeLst/>
 </a:theme>
+</file>
+
+<file path=ppt/theme/theme2.xml><?xml version="1.0" encoding="utf-8"?>
+<a:theme xmlns:a="http://schemas.openxmlformats.org/drawingml/2006/main" name="Office Theme">
+  <a:themeElements>
+    <a:clrScheme name="Office">
+      <a:dk1>
+        <a:sysClr val="windowText" lastClr="000000"/>
+      </a:dk1>
+      <a:lt1>
+        <a:sysClr val="window" lastClr="FFFFFF"/>
+      </a:lt1>
+      <a:dk2>
+        <a:srgbClr val="0E2841"/>
+      </a:dk2>
+      <a:lt2>
+        <a:srgbClr val="E8E8E8"/>
+      </a:lt2>
+      <a:accent1>
+        <a:srgbClr val="156082"/>
+      </a:accent1>
+      <a:accent2>
+        <a:srgbClr val="E97132"/>
+      </a:accent2>
+      <a:accent3>
+        <a:srgbClr val="196B24"/>
+      </a:accent3>
+      <a:accent4>
+        <a:srgbClr val="0F9ED5"/>
+      </a:accent4>
+      <a:accent5>
+        <a:srgbClr val="A02B93"/>
+      </a:accent5>
+      <a:accent6>
+        <a:srgbClr val="4EA72E"/>
+      </a:accent6>
+      <a:hlink>
+        <a:srgbClr val="467886"/>
+      </a:hlink>
+      <a:folHlink>
+        <a:srgbClr val="96607D"/>
+      </a:folHlink>
+    </a:clrScheme>
+    <a:fontScheme name="Office">
+      <a:majorFont>
+        <a:latin typeface="Aptos Display" panose="02110004020202020204"/>
+        <a:ea typeface=""/>
+        <a:cs typeface=""/>
+        <a:font script="Jpan" typeface="游ゴシック Light"/>
+        <a:font script="Hang" typeface="맑은 고딕"/>
+        <a:font script="Hans" typeface="等线 Light"/>
+        <a:font script="Hant" typeface="新細明體"/>
+        <a:font script="Arab" typeface="Times New Roman"/>
+        <a:font script="Hebr" typeface="Times New Roman"/>
+        <a:font script="Thai" typeface="Angsana New"/>
+        <a:font script="Ethi" typeface="Nyala"/>
+        <a:font script="Beng" typeface="Vrinda"/>
+        <a:font script="Gujr" typeface="Shruti"/>
+        <a:font script="Khmr" typeface="MoolBoran"/>
+        <a:font script="Knda" typeface="Tunga"/>
+        <a:font script="Guru" typeface="Raavi"/>
+        <a:font script="Cans" typeface="Euphemia"/>
+        <a:font script="Cher" typeface="Plantagenet Cherokee"/>
+        <a:font script="Yiii" typeface="Microsoft Yi Baiti"/>
+        <a:font script="Tibt" typeface="Microsoft Himalaya"/>
+        <a:font script="Thaa" typeface="MV Boli"/>
+        <a:font script="Deva" typeface="Mangal"/>
+        <a:font script="Telu" typeface="Gautami"/>
+        <a:font script="Taml" typeface="Latha"/>
+        <a:font script="Syrc" typeface="Estrangelo Edessa"/>
+        <a:font script="Orya" typeface="Kalinga"/>
+        <a:font script="Mlym" typeface="Kartika"/>
+        <a:font script="Laoo" typeface="DokChampa"/>
+        <a:font script="Sinh" typeface="Iskoola Pota"/>
+        <a:font script="Mong" typeface="Mongolian Baiti"/>
+        <a:font script="Viet" typeface="Times New Roman"/>
+        <a:font script="Uigh" typeface="Microsoft Uighur"/>
+        <a:font script="Geor" typeface="Sylfaen"/>
+        <a:font script="Armn" typeface="Arial"/>
+        <a:font script="Bugi" typeface="Leelawadee UI"/>
+        <a:font script="Bopo" typeface="Microsoft JhengHei"/>
+        <a:font script="Java" typeface="Javanese Text"/>
+        <a:font script="Lisu" typeface="Segoe UI"/>
+        <a:font script="Mymr" typeface="Myanmar Text"/>
+        <a:font script="Nkoo" typeface="Ebrima"/>
+        <a:font script="Olck" typeface="Nirmala UI"/>
+        <a:font script="Osma" typeface="Ebrima"/>
+        <a:font script="Phag" typeface="Phagspa"/>
+        <a:font script="Syrn" typeface="Estrangelo Edessa"/>
+        <a:font script="Syrj" typeface="Estrangelo Edessa"/>
+        <a:font script="Syre" typeface="Estrangelo Edessa"/>
+        <a:font script="Sora" typeface="Nirmala UI"/>
+        <a:font script="Tale" typeface="Microsoft Tai Le"/>
+        <a:font script="Talu" typeface="Microsoft New Tai Lue"/>
+        <a:font script="Tfng" typeface="Ebrima"/>
+      </a:majorFont>
+      <a:minorFont>
+        <a:latin typeface="Aptos" panose="02110004020202020204"/>
+        <a:ea typeface=""/>
+        <a:cs typeface=""/>
+        <a:font script="Jpan" typeface="游ゴシック"/>
+        <a:font script="Hang" typeface="맑은 고딕"/>
+        <a:font script="Hans" typeface="等线"/>
+        <a:font script="Hant" typeface="新細明體"/>
+        <a:font script="Arab" typeface="Arial"/>
+        <a:font script="Hebr" typeface="Arial"/>
+        <a:font script="Thai" typeface="Cordia New"/>
+        <a:font script="Ethi" typeface="Nyala"/>
+        <a:font script="Beng" typeface="Vrinda"/>
+        <a:font script="Gujr" typeface="Shruti"/>
+        <a:font script="Khmr" typeface="DaunPenh"/>
+        <a:font script="Knda" typeface="Tunga"/>
+        <a:font script="Guru" typeface="Raavi"/>
+        <a:font script="Cans" typeface="Euphemia"/>
+        <a:font script="Cher" typeface="Plantagenet Cherokee"/>
+        <a:font script="Yiii" typeface="Microsoft Yi Baiti"/>
+        <a:font script="Tibt" typeface="Microsoft Himalaya"/>
+        <a:font script="Thaa" typeface="MV Boli"/>
+        <a:font script="Deva" typeface="Mangal"/>
+        <a:font script="Telu" typeface="Gautami"/>
+        <a:font script="Taml" typeface="Latha"/>
+        <a:font script="Syrc" typeface="Estrangelo Edessa"/>
+        <a:font script="Orya" typeface="Kalinga"/>
+        <a:font script="Mlym" typeface="Kartika"/>
+        <a:font script="Laoo" typeface="DokChampa"/>
+        <a:font script="Sinh" typeface="Iskoola Pota"/>
+        <a:font script="Mong" typeface="Mongolian Baiti"/>
+        <a:font script="Viet" typeface="Arial"/>
+        <a:font script="Uigh" typeface="Microsoft Uighur"/>
+        <a:font script="Geor" typeface="Sylfaen"/>
+        <a:font script="Armn" typeface="Arial"/>
+        <a:font script="Bugi" typeface="Leelawadee UI"/>
+        <a:font script="Bopo" typeface="Microsoft JhengHei"/>
+        <a:font script="Java" typeface="Javanese Text"/>
+        <a:font script="Lisu" typeface="Segoe UI"/>
+        <a:font script="Mymr" typeface="Myanmar Text"/>
+        <a:font script="Nkoo" typeface="Ebrima"/>
+        <a:font script="Olck" typeface="Nirmala UI"/>
+        <a:font script="Osma" typeface="Ebrima"/>
+        <a:font script="Phag" typeface="Phagspa"/>
+        <a:font script="Syrn" typeface="Estrangelo Edessa"/>
+        <a:font script="Syrj" typeface="Estrangelo Edessa"/>
+        <a:font script="Syre" typeface="Estrangelo Edessa"/>
+        <a:font script="Sora" typeface="Nirmala UI"/>
+        <a:font script="Tale" typeface="Microsoft Tai Le"/>
+        <a:font script="Talu" typeface="Microsoft New Tai Lue"/>
+        <a:font script="Tfng" typeface="Ebrima"/>
+      </a:minorFont>
+    </a:fontScheme>
+    <a:fmtScheme name="Office">
+      <a:fillStyleLst>
+        <a:solidFill>
+          <a:schemeClr val="phClr"/>
+        </a:solidFill>
+        <a:gradFill rotWithShape="1">
+          <a:gsLst>
+            <a:gs pos="0">
+              <a:schemeClr val="phClr">
+                <a:lumMod val="110000"/>
+                <a:satMod val="105000"/>
+                <a:tint val="67000"/>
+              </a:schemeClr>
+            </a:gs>
+            <a:gs pos="50000">
+              <a:schemeClr val="phClr">
+                <a:lumMod val="105000"/>
+                <a:satMod val="103000"/>
+                <a:tint val="73000"/>
+              </a:schemeClr>
+            </a:gs>
+            <a:gs pos="100000">
+              <a:schemeClr val="phClr">
+                <a:lumMod val="105000"/>
+                <a:satMod val="109000"/>
+                <a:tint val="81000"/>
+              </a:schemeClr>
+            </a:gs>
+          </a:gsLst>
+          <a:lin ang="5400000" scaled="0"/>
+        </a:gradFill>
+        <a:gradFill rotWithShape="1">
+          <a:gsLst>
+            <a:gs pos="0">
+              <a:schemeClr val="phClr">
+                <a:satMod val="103000"/>
+                <a:lumMod val="102000"/>
+                <a:tint val="94000"/>
+              </a:schemeClr>
+            </a:gs>
+            <a:gs pos="50000">
+              <a:schemeClr val="phClr">
+                <a:satMod val="110000"/>
+                <a:lumMod val="100000"/>
+                <a:shade val="100000"/>
+              </a:schemeClr>
+            </a:gs>
+            <a:gs pos="100000">
+              <a:schemeClr val="phClr">
+                <a:lumMod val="99000"/>
+                <a:satMod val="120000"/>
+                <a:shade val="78000"/>
+              </a:schemeClr>
+            </a:gs>
+          </a:gsLst>
+          <a:lin ang="5400000" scaled="0"/>
+        </a:gradFill>
+      </a:fillStyleLst>
+      <a:lnStyleLst>
+        <a:ln w="12700" cap="flat" cmpd="sng" algn="ctr">
+          <a:solidFill>
+            <a:schemeClr val="phClr"/>
+          </a:solidFill>
+          <a:prstDash val="solid"/>
+          <a:miter lim="800000"/>
+        </a:ln>
+        <a:ln w="19050" cap="flat" cmpd="sng" algn="ctr">
+          <a:solidFill>
+            <a:schemeClr val="phClr"/>
+          </a:solidFill>
+          <a:prstDash val="solid"/>
+          <a:miter lim="800000"/>
+        </a:ln>
+        <a:ln w="25400" cap="flat" cmpd="sng" algn="ctr">
+          <a:solidFill>
+            <a:schemeClr val="phClr"/>
+          </a:solidFill>
+          <a:prstDash val="solid"/>
+          <a:miter lim="800000"/>
+        </a:ln>
+      </a:lnStyleLst>
+      <a:effectStyleLst>
+        <a:effectStyle>
+          <a:effectLst/>
+        </a:effectStyle>
+        <a:effectStyle>
+          <a:effectLst/>
+        </a:effectStyle>
+        <a:effectStyle>
+          <a:effectLst>
+            <a:outerShdw blurRad="57150" dist="19050" dir="5400000" algn="ctr" rotWithShape="0">
+              <a:srgbClr val="000000">
+                <a:alpha val="63000"/>
+              </a:srgbClr>
+            </a:outerShdw>
+          </a:effectLst>
+        </a:effectStyle>
+      </a:effectStyleLst>
+      <a:bgFillStyleLst>
+        <a:solidFill>
+          <a:schemeClr val="phClr"/>
+        </a:solidFill>
+        <a:solidFill>
+          <a:schemeClr val="phClr">
+            <a:tint val="95000"/>
+            <a:satMod val="170000"/>
+          </a:schemeClr>
+        </a:solidFill>
+        <a:gradFill rotWithShape="1">
+          <a:gsLst>
+            <a:gs pos="0">
+              <a:schemeClr val="phClr">
+                <a:tint val="93000"/>
+                <a:satMod val="150000"/>
+                <a:shade val="98000"/>
+                <a:lumMod val="102000"/>
+              </a:schemeClr>
+            </a:gs>
+            <a:gs pos="50000">
+              <a:schemeClr val="phClr">
+                <a:tint val="98000"/>
+                <a:satMod val="130000"/>
+                <a:shade val="90000"/>
+                <a:lumMod val="103000"/>
+              </a:schemeClr>
+            </a:gs>
+            <a:gs pos="100000">
+              <a:schemeClr val="phClr">
+                <a:shade val="63000"/>
+                <a:satMod val="120000"/>
+              </a:schemeClr>
+            </a:gs>
+          </a:gsLst>
+          <a:lin ang="5400000" scaled="0"/>
+        </a:gradFill>
+      </a:bgFillStyleLst>
+    </a:fmtScheme>
+  </a:themeElements>
+  <a:objectDefaults>
+    <a:lnDef>
+      <a:spPr/>
+      <a:bodyPr/>
+      <a:lstStyle/>
+      <a:style>
+        <a:lnRef idx="2">
+          <a:schemeClr val="accent1"/>
+        </a:lnRef>
+        <a:fillRef idx="0">
+          <a:schemeClr val="accent1"/>
+        </a:fillRef>
+        <a:effectRef idx="1">
+          <a:schemeClr val="accent1"/>
+        </a:effectRef>
+        <a:fontRef idx="minor">
+          <a:schemeClr val="tx1"/>
+        </a:fontRef>
+      </a:style>
+    </a:lnDef>
+  </a:objectDefaults>
+  <a:extraClrSchemeLst/>
+  <a:extLst>
+    <a:ext uri="{05A4C25C-085E-4340-85A3-A5531E510DB2}">
+      <thm15:themeFamily xmlns:thm15="http://schemas.microsoft.com/office/thememl/2012/main" name="Office Theme" id="{2E142A2C-CD16-42D6-873A-C26D2A0506FA}" vid="{1BDDFF52-6CD6-40A5-AB3C-68EB2F1E4D0A}"/>
+    </a:ext>
+  </a:extLst>
+</a:theme>
 </file>
</xml_diff>